<commit_message>
Remove temporary file ~$SIMD_Bitonic_Sort_v4.pptx
</commit_message>
<xml_diff>
--- a/SIMD_Bitonic_Sort_v3.pptx
+++ b/SIMD_Bitonic_Sort_v3.pptx
@@ -5,21 +5,21 @@
     <p:sldMasterId id="2147483648" r:id="rId1"/>
   </p:sldMasterIdLst>
   <p:sldIdLst>
-    <p:sldId id="256" r:id="rId7"/>
-    <p:sldId id="257" r:id="rId8"/>
-    <p:sldId id="258" r:id="rId9"/>
-    <p:sldId id="259" r:id="rId10"/>
-    <p:sldId id="260" r:id="rId11"/>
-    <p:sldId id="261" r:id="rId12"/>
-    <p:sldId id="262" r:id="rId13"/>
-    <p:sldId id="263" r:id="rId14"/>
-    <p:sldId id="264" r:id="rId15"/>
-    <p:sldId id="265" r:id="rId16"/>
-    <p:sldId id="266" r:id="rId17"/>
-    <p:sldId id="267" r:id="rId18"/>
-    <p:sldId id="268" r:id="rId19"/>
+    <p:sldId id="256" r:id="rId2"/>
+    <p:sldId id="257" r:id="rId3"/>
+    <p:sldId id="258" r:id="rId4"/>
+    <p:sldId id="259" r:id="rId5"/>
+    <p:sldId id="260" r:id="rId6"/>
+    <p:sldId id="261" r:id="rId7"/>
+    <p:sldId id="262" r:id="rId8"/>
+    <p:sldId id="263" r:id="rId9"/>
+    <p:sldId id="264" r:id="rId10"/>
+    <p:sldId id="265" r:id="rId11"/>
+    <p:sldId id="266" r:id="rId12"/>
+    <p:sldId id="267" r:id="rId13"/>
+    <p:sldId id="268" r:id="rId14"/>
   </p:sldIdLst>
-  <p:sldSz cx="12188952" cy="6858000" type="screen4x3"/>
+  <p:sldSz cx="12188825" cy="6858000"/>
   <p:notesSz cx="6858000" cy="9144000"/>
   <p:defaultTextStyle>
     <a:defPPr>
@@ -116,6 +116,22 @@
       </a:defRPr>
     </a:lvl9pPr>
   </p:defaultTextStyle>
+  <p:extLst>
+    <p:ext uri="{EFAFB233-063F-42B5-8137-9DF3F51BA10A}">
+      <p15:sldGuideLst xmlns:p15="http://schemas.microsoft.com/office/powerpoint/2012/main">
+        <p15:guide id="1" orient="horz" pos="2160">
+          <p15:clr>
+            <a:srgbClr val="A4A3A4"/>
+          </p15:clr>
+        </p15:guide>
+        <p15:guide id="2" pos="2880">
+          <p15:clr>
+            <a:srgbClr val="A4A3A4"/>
+          </p15:clr>
+        </p15:guide>
+      </p15:sldGuideLst>
+    </p:ext>
+  </p:extLst>
 </p:presentation>
 </file>
 
@@ -157,10 +173,9 @@
           <a:lstStyle/>
           <a:p>
             <a:r>
-              <a:rPr lang="en-US" smtClean="0"/>
+              <a:rPr lang="en-US"/>
               <a:t>Click to edit Master title style</a:t>
             </a:r>
-            <a:endParaRPr lang="en-US"/>
           </a:p>
         </p:txBody>
       </p:sp>
@@ -276,10 +291,9 @@
           </a:lstStyle>
           <a:p>
             <a:r>
-              <a:rPr lang="en-US" smtClean="0"/>
+              <a:rPr lang="en-US"/>
               <a:t>Click to edit Master subtitle style</a:t>
             </a:r>
-            <a:endParaRPr lang="en-US"/>
           </a:p>
         </p:txBody>
       </p:sp>
@@ -300,7 +314,7 @@
           <a:p>
             <a:fld id="{5BCAD085-E8A6-8845-BD4E-CB4CCA059FC4}" type="datetimeFigureOut">
               <a:rPr lang="en-US" smtClean="0"/>
-              <a:t>1/27/13</a:t>
+              <a:t>5/9/2026</a:t>
             </a:fld>
             <a:endParaRPr lang="en-US"/>
           </a:p>
@@ -394,10 +408,9 @@
           <a:lstStyle/>
           <a:p>
             <a:r>
-              <a:rPr lang="en-US" smtClean="0"/>
+              <a:rPr lang="en-US"/>
               <a:t>Click to edit Master title style</a:t>
             </a:r>
-            <a:endParaRPr lang="en-US"/>
           </a:p>
         </p:txBody>
       </p:sp>
@@ -418,38 +431,37 @@
           <a:p>
             <a:pPr lvl="0"/>
             <a:r>
-              <a:rPr lang="en-US" smtClean="0"/>
+              <a:rPr lang="en-US"/>
               <a:t>Click to edit Master text styles</a:t>
             </a:r>
           </a:p>
           <a:p>
             <a:pPr lvl="1"/>
             <a:r>
-              <a:rPr lang="en-US" smtClean="0"/>
+              <a:rPr lang="en-US"/>
               <a:t>Second level</a:t>
             </a:r>
           </a:p>
           <a:p>
             <a:pPr lvl="2"/>
             <a:r>
-              <a:rPr lang="en-US" smtClean="0"/>
+              <a:rPr lang="en-US"/>
               <a:t>Third level</a:t>
             </a:r>
           </a:p>
           <a:p>
             <a:pPr lvl="3"/>
             <a:r>
-              <a:rPr lang="en-US" smtClean="0"/>
+              <a:rPr lang="en-US"/>
               <a:t>Fourth level</a:t>
             </a:r>
           </a:p>
           <a:p>
             <a:pPr lvl="4"/>
             <a:r>
-              <a:rPr lang="en-US" smtClean="0"/>
+              <a:rPr lang="en-US"/>
               <a:t>Fifth level</a:t>
             </a:r>
-            <a:endParaRPr lang="en-US"/>
           </a:p>
         </p:txBody>
       </p:sp>
@@ -470,7 +482,7 @@
           <a:p>
             <a:fld id="{5BCAD085-E8A6-8845-BD4E-CB4CCA059FC4}" type="datetimeFigureOut">
               <a:rPr lang="en-US" smtClean="0"/>
-              <a:t>1/27/13</a:t>
+              <a:t>5/9/2026</a:t>
             </a:fld>
             <a:endParaRPr lang="en-US"/>
           </a:p>
@@ -569,10 +581,9 @@
           <a:lstStyle/>
           <a:p>
             <a:r>
-              <a:rPr lang="en-US" smtClean="0"/>
+              <a:rPr lang="en-US"/>
               <a:t>Click to edit Master title style</a:t>
             </a:r>
-            <a:endParaRPr lang="en-US"/>
           </a:p>
         </p:txBody>
       </p:sp>
@@ -598,38 +609,37 @@
           <a:p>
             <a:pPr lvl="0"/>
             <a:r>
-              <a:rPr lang="en-US" smtClean="0"/>
+              <a:rPr lang="en-US"/>
               <a:t>Click to edit Master text styles</a:t>
             </a:r>
           </a:p>
           <a:p>
             <a:pPr lvl="1"/>
             <a:r>
-              <a:rPr lang="en-US" smtClean="0"/>
+              <a:rPr lang="en-US"/>
               <a:t>Second level</a:t>
             </a:r>
           </a:p>
           <a:p>
             <a:pPr lvl="2"/>
             <a:r>
-              <a:rPr lang="en-US" smtClean="0"/>
+              <a:rPr lang="en-US"/>
               <a:t>Third level</a:t>
             </a:r>
           </a:p>
           <a:p>
             <a:pPr lvl="3"/>
             <a:r>
-              <a:rPr lang="en-US" smtClean="0"/>
+              <a:rPr lang="en-US"/>
               <a:t>Fourth level</a:t>
             </a:r>
           </a:p>
           <a:p>
             <a:pPr lvl="4"/>
             <a:r>
-              <a:rPr lang="en-US" smtClean="0"/>
+              <a:rPr lang="en-US"/>
               <a:t>Fifth level</a:t>
             </a:r>
-            <a:endParaRPr lang="en-US"/>
           </a:p>
         </p:txBody>
       </p:sp>
@@ -650,7 +660,7 @@
           <a:p>
             <a:fld id="{5BCAD085-E8A6-8845-BD4E-CB4CCA059FC4}" type="datetimeFigureOut">
               <a:rPr lang="en-US" smtClean="0"/>
-              <a:t>1/27/13</a:t>
+              <a:t>5/9/2026</a:t>
             </a:fld>
             <a:endParaRPr lang="en-US"/>
           </a:p>
@@ -744,10 +754,9 @@
           <a:lstStyle/>
           <a:p>
             <a:r>
-              <a:rPr lang="en-US" smtClean="0"/>
+              <a:rPr lang="en-US"/>
               <a:t>Click to edit Master title style</a:t>
             </a:r>
-            <a:endParaRPr lang="en-US"/>
           </a:p>
         </p:txBody>
       </p:sp>
@@ -768,38 +777,37 @@
           <a:p>
             <a:pPr lvl="0"/>
             <a:r>
-              <a:rPr lang="en-US" smtClean="0"/>
+              <a:rPr lang="en-US"/>
               <a:t>Click to edit Master text styles</a:t>
             </a:r>
           </a:p>
           <a:p>
             <a:pPr lvl="1"/>
             <a:r>
-              <a:rPr lang="en-US" smtClean="0"/>
+              <a:rPr lang="en-US"/>
               <a:t>Second level</a:t>
             </a:r>
           </a:p>
           <a:p>
             <a:pPr lvl="2"/>
             <a:r>
-              <a:rPr lang="en-US" smtClean="0"/>
+              <a:rPr lang="en-US"/>
               <a:t>Third level</a:t>
             </a:r>
           </a:p>
           <a:p>
             <a:pPr lvl="3"/>
             <a:r>
-              <a:rPr lang="en-US" smtClean="0"/>
+              <a:rPr lang="en-US"/>
               <a:t>Fourth level</a:t>
             </a:r>
           </a:p>
           <a:p>
             <a:pPr lvl="4"/>
             <a:r>
-              <a:rPr lang="en-US" smtClean="0"/>
+              <a:rPr lang="en-US"/>
               <a:t>Fifth level</a:t>
             </a:r>
-            <a:endParaRPr lang="en-US"/>
           </a:p>
         </p:txBody>
       </p:sp>
@@ -820,7 +828,7 @@
           <a:p>
             <a:fld id="{5BCAD085-E8A6-8845-BD4E-CB4CCA059FC4}" type="datetimeFigureOut">
               <a:rPr lang="en-US" smtClean="0"/>
-              <a:t>1/27/13</a:t>
+              <a:t>5/9/2026</a:t>
             </a:fld>
             <a:endParaRPr lang="en-US"/>
           </a:p>
@@ -923,10 +931,9 @@
           </a:lstStyle>
           <a:p>
             <a:r>
-              <a:rPr lang="en-US" smtClean="0"/>
+              <a:rPr lang="en-US"/>
               <a:t>Click to edit Master title style</a:t>
             </a:r>
-            <a:endParaRPr lang="en-US"/>
           </a:p>
         </p:txBody>
       </p:sp>
@@ -1043,7 +1050,7 @@
           <a:p>
             <a:pPr lvl="0"/>
             <a:r>
-              <a:rPr lang="en-US" smtClean="0"/>
+              <a:rPr lang="en-US"/>
               <a:t>Click to edit Master text styles</a:t>
             </a:r>
           </a:p>
@@ -1066,7 +1073,7 @@
           <a:p>
             <a:fld id="{5BCAD085-E8A6-8845-BD4E-CB4CCA059FC4}" type="datetimeFigureOut">
               <a:rPr lang="en-US" smtClean="0"/>
-              <a:t>1/27/13</a:t>
+              <a:t>5/9/2026</a:t>
             </a:fld>
             <a:endParaRPr lang="en-US"/>
           </a:p>
@@ -1160,10 +1167,9 @@
           <a:lstStyle/>
           <a:p>
             <a:r>
-              <a:rPr lang="en-US" smtClean="0"/>
+              <a:rPr lang="en-US"/>
               <a:t>Click to edit Master title style</a:t>
             </a:r>
-            <a:endParaRPr lang="en-US"/>
           </a:p>
         </p:txBody>
       </p:sp>
@@ -1217,38 +1223,37 @@
           <a:p>
             <a:pPr lvl="0"/>
             <a:r>
-              <a:rPr lang="en-US" smtClean="0"/>
+              <a:rPr lang="en-US"/>
               <a:t>Click to edit Master text styles</a:t>
             </a:r>
           </a:p>
           <a:p>
             <a:pPr lvl="1"/>
             <a:r>
-              <a:rPr lang="en-US" smtClean="0"/>
+              <a:rPr lang="en-US"/>
               <a:t>Second level</a:t>
             </a:r>
           </a:p>
           <a:p>
             <a:pPr lvl="2"/>
             <a:r>
-              <a:rPr lang="en-US" smtClean="0"/>
+              <a:rPr lang="en-US"/>
               <a:t>Third level</a:t>
             </a:r>
           </a:p>
           <a:p>
             <a:pPr lvl="3"/>
             <a:r>
-              <a:rPr lang="en-US" smtClean="0"/>
+              <a:rPr lang="en-US"/>
               <a:t>Fourth level</a:t>
             </a:r>
           </a:p>
           <a:p>
             <a:pPr lvl="4"/>
             <a:r>
-              <a:rPr lang="en-US" smtClean="0"/>
+              <a:rPr lang="en-US"/>
               <a:t>Fifth level</a:t>
             </a:r>
-            <a:endParaRPr lang="en-US"/>
           </a:p>
         </p:txBody>
       </p:sp>
@@ -1302,38 +1307,37 @@
           <a:p>
             <a:pPr lvl="0"/>
             <a:r>
-              <a:rPr lang="en-US" smtClean="0"/>
+              <a:rPr lang="en-US"/>
               <a:t>Click to edit Master text styles</a:t>
             </a:r>
           </a:p>
           <a:p>
             <a:pPr lvl="1"/>
             <a:r>
-              <a:rPr lang="en-US" smtClean="0"/>
+              <a:rPr lang="en-US"/>
               <a:t>Second level</a:t>
             </a:r>
           </a:p>
           <a:p>
             <a:pPr lvl="2"/>
             <a:r>
-              <a:rPr lang="en-US" smtClean="0"/>
+              <a:rPr lang="en-US"/>
               <a:t>Third level</a:t>
             </a:r>
           </a:p>
           <a:p>
             <a:pPr lvl="3"/>
             <a:r>
-              <a:rPr lang="en-US" smtClean="0"/>
+              <a:rPr lang="en-US"/>
               <a:t>Fourth level</a:t>
             </a:r>
           </a:p>
           <a:p>
             <a:pPr lvl="4"/>
             <a:r>
-              <a:rPr lang="en-US" smtClean="0"/>
+              <a:rPr lang="en-US"/>
               <a:t>Fifth level</a:t>
             </a:r>
-            <a:endParaRPr lang="en-US"/>
           </a:p>
         </p:txBody>
       </p:sp>
@@ -1354,7 +1358,7 @@
           <a:p>
             <a:fld id="{5BCAD085-E8A6-8845-BD4E-CB4CCA059FC4}" type="datetimeFigureOut">
               <a:rPr lang="en-US" smtClean="0"/>
-              <a:t>1/27/13</a:t>
+              <a:t>5/9/2026</a:t>
             </a:fld>
             <a:endParaRPr lang="en-US"/>
           </a:p>
@@ -1452,10 +1456,9 @@
           </a:lstStyle>
           <a:p>
             <a:r>
-              <a:rPr lang="en-US" smtClean="0"/>
+              <a:rPr lang="en-US"/>
               <a:t>Click to edit Master title style</a:t>
             </a:r>
-            <a:endParaRPr lang="en-US"/>
           </a:p>
         </p:txBody>
       </p:sp>
@@ -1518,7 +1521,7 @@
           <a:p>
             <a:pPr lvl="0"/>
             <a:r>
-              <a:rPr lang="en-US" smtClean="0"/>
+              <a:rPr lang="en-US"/>
               <a:t>Click to edit Master text styles</a:t>
             </a:r>
           </a:p>
@@ -1574,38 +1577,37 @@
           <a:p>
             <a:pPr lvl="0"/>
             <a:r>
-              <a:rPr lang="en-US" smtClean="0"/>
+              <a:rPr lang="en-US"/>
               <a:t>Click to edit Master text styles</a:t>
             </a:r>
           </a:p>
           <a:p>
             <a:pPr lvl="1"/>
             <a:r>
-              <a:rPr lang="en-US" smtClean="0"/>
+              <a:rPr lang="en-US"/>
               <a:t>Second level</a:t>
             </a:r>
           </a:p>
           <a:p>
             <a:pPr lvl="2"/>
             <a:r>
-              <a:rPr lang="en-US" smtClean="0"/>
+              <a:rPr lang="en-US"/>
               <a:t>Third level</a:t>
             </a:r>
           </a:p>
           <a:p>
             <a:pPr lvl="3"/>
             <a:r>
-              <a:rPr lang="en-US" smtClean="0"/>
+              <a:rPr lang="en-US"/>
               <a:t>Fourth level</a:t>
             </a:r>
           </a:p>
           <a:p>
             <a:pPr lvl="4"/>
             <a:r>
-              <a:rPr lang="en-US" smtClean="0"/>
+              <a:rPr lang="en-US"/>
               <a:t>Fifth level</a:t>
             </a:r>
-            <a:endParaRPr lang="en-US"/>
           </a:p>
         </p:txBody>
       </p:sp>
@@ -1668,7 +1670,7 @@
           <a:p>
             <a:pPr lvl="0"/>
             <a:r>
-              <a:rPr lang="en-US" smtClean="0"/>
+              <a:rPr lang="en-US"/>
               <a:t>Click to edit Master text styles</a:t>
             </a:r>
           </a:p>
@@ -1724,38 +1726,37 @@
           <a:p>
             <a:pPr lvl="0"/>
             <a:r>
-              <a:rPr lang="en-US" smtClean="0"/>
+              <a:rPr lang="en-US"/>
               <a:t>Click to edit Master text styles</a:t>
             </a:r>
           </a:p>
           <a:p>
             <a:pPr lvl="1"/>
             <a:r>
-              <a:rPr lang="en-US" smtClean="0"/>
+              <a:rPr lang="en-US"/>
               <a:t>Second level</a:t>
             </a:r>
           </a:p>
           <a:p>
             <a:pPr lvl="2"/>
             <a:r>
-              <a:rPr lang="en-US" smtClean="0"/>
+              <a:rPr lang="en-US"/>
               <a:t>Third level</a:t>
             </a:r>
           </a:p>
           <a:p>
             <a:pPr lvl="3"/>
             <a:r>
-              <a:rPr lang="en-US" smtClean="0"/>
+              <a:rPr lang="en-US"/>
               <a:t>Fourth level</a:t>
             </a:r>
           </a:p>
           <a:p>
             <a:pPr lvl="4"/>
             <a:r>
-              <a:rPr lang="en-US" smtClean="0"/>
+              <a:rPr lang="en-US"/>
               <a:t>Fifth level</a:t>
             </a:r>
-            <a:endParaRPr lang="en-US"/>
           </a:p>
         </p:txBody>
       </p:sp>
@@ -1776,7 +1777,7 @@
           <a:p>
             <a:fld id="{5BCAD085-E8A6-8845-BD4E-CB4CCA059FC4}" type="datetimeFigureOut">
               <a:rPr lang="en-US" smtClean="0"/>
-              <a:t>1/27/13</a:t>
+              <a:t>5/9/2026</a:t>
             </a:fld>
             <a:endParaRPr lang="en-US"/>
           </a:p>
@@ -1870,10 +1871,9 @@
           <a:lstStyle/>
           <a:p>
             <a:r>
-              <a:rPr lang="en-US" smtClean="0"/>
+              <a:rPr lang="en-US"/>
               <a:t>Click to edit Master title style</a:t>
             </a:r>
-            <a:endParaRPr lang="en-US"/>
           </a:p>
         </p:txBody>
       </p:sp>
@@ -1894,7 +1894,7 @@
           <a:p>
             <a:fld id="{5BCAD085-E8A6-8845-BD4E-CB4CCA059FC4}" type="datetimeFigureOut">
               <a:rPr lang="en-US" smtClean="0"/>
-              <a:t>1/27/13</a:t>
+              <a:t>5/9/2026</a:t>
             </a:fld>
             <a:endParaRPr lang="en-US"/>
           </a:p>
@@ -1989,7 +1989,7 @@
           <a:p>
             <a:fld id="{5BCAD085-E8A6-8845-BD4E-CB4CCA059FC4}" type="datetimeFigureOut">
               <a:rPr lang="en-US" smtClean="0"/>
-              <a:t>1/27/13</a:t>
+              <a:t>5/9/2026</a:t>
             </a:fld>
             <a:endParaRPr lang="en-US"/>
           </a:p>
@@ -2092,10 +2092,9 @@
           </a:lstStyle>
           <a:p>
             <a:r>
-              <a:rPr lang="en-US" smtClean="0"/>
+              <a:rPr lang="en-US"/>
               <a:t>Click to edit Master title style</a:t>
             </a:r>
-            <a:endParaRPr lang="en-US"/>
           </a:p>
         </p:txBody>
       </p:sp>
@@ -2149,38 +2148,37 @@
           <a:p>
             <a:pPr lvl="0"/>
             <a:r>
-              <a:rPr lang="en-US" smtClean="0"/>
+              <a:rPr lang="en-US"/>
               <a:t>Click to edit Master text styles</a:t>
             </a:r>
           </a:p>
           <a:p>
             <a:pPr lvl="1"/>
             <a:r>
-              <a:rPr lang="en-US" smtClean="0"/>
+              <a:rPr lang="en-US"/>
               <a:t>Second level</a:t>
             </a:r>
           </a:p>
           <a:p>
             <a:pPr lvl="2"/>
             <a:r>
-              <a:rPr lang="en-US" smtClean="0"/>
+              <a:rPr lang="en-US"/>
               <a:t>Third level</a:t>
             </a:r>
           </a:p>
           <a:p>
             <a:pPr lvl="3"/>
             <a:r>
-              <a:rPr lang="en-US" smtClean="0"/>
+              <a:rPr lang="en-US"/>
               <a:t>Fourth level</a:t>
             </a:r>
           </a:p>
           <a:p>
             <a:pPr lvl="4"/>
             <a:r>
-              <a:rPr lang="en-US" smtClean="0"/>
+              <a:rPr lang="en-US"/>
               <a:t>Fifth level</a:t>
             </a:r>
-            <a:endParaRPr lang="en-US"/>
           </a:p>
         </p:txBody>
       </p:sp>
@@ -2243,7 +2241,7 @@
           <a:p>
             <a:pPr lvl="0"/>
             <a:r>
-              <a:rPr lang="en-US" smtClean="0"/>
+              <a:rPr lang="en-US"/>
               <a:t>Click to edit Master text styles</a:t>
             </a:r>
           </a:p>
@@ -2266,7 +2264,7 @@
           <a:p>
             <a:fld id="{5BCAD085-E8A6-8845-BD4E-CB4CCA059FC4}" type="datetimeFigureOut">
               <a:rPr lang="en-US" smtClean="0"/>
-              <a:t>1/27/13</a:t>
+              <a:t>5/9/2026</a:t>
             </a:fld>
             <a:endParaRPr lang="en-US"/>
           </a:p>
@@ -2369,10 +2367,9 @@
           </a:lstStyle>
           <a:p>
             <a:r>
-              <a:rPr lang="en-US" smtClean="0"/>
+              <a:rPr lang="en-US"/>
               <a:t>Click to edit Master title style</a:t>
             </a:r>
-            <a:endParaRPr lang="en-US"/>
           </a:p>
         </p:txBody>
       </p:sp>
@@ -2496,7 +2493,7 @@
           <a:p>
             <a:pPr lvl="0"/>
             <a:r>
-              <a:rPr lang="en-US" smtClean="0"/>
+              <a:rPr lang="en-US"/>
               <a:t>Click to edit Master text styles</a:t>
             </a:r>
           </a:p>
@@ -2519,7 +2516,7 @@
           <a:p>
             <a:fld id="{5BCAD085-E8A6-8845-BD4E-CB4CCA059FC4}" type="datetimeFigureOut">
               <a:rPr lang="en-US" smtClean="0"/>
-              <a:t>1/27/13</a:t>
+              <a:t>5/9/2026</a:t>
             </a:fld>
             <a:endParaRPr lang="en-US"/>
           </a:p>
@@ -2628,10 +2625,9 @@
           <a:lstStyle/>
           <a:p>
             <a:r>
-              <a:rPr lang="en-US" smtClean="0"/>
+              <a:rPr lang="en-US"/>
               <a:t>Click to edit Master title style</a:t>
             </a:r>
-            <a:endParaRPr lang="en-US"/>
           </a:p>
         </p:txBody>
       </p:sp>
@@ -2662,38 +2658,37 @@
           <a:p>
             <a:pPr lvl="0"/>
             <a:r>
-              <a:rPr lang="en-US" smtClean="0"/>
+              <a:rPr lang="en-US"/>
               <a:t>Click to edit Master text styles</a:t>
             </a:r>
           </a:p>
           <a:p>
             <a:pPr lvl="1"/>
             <a:r>
-              <a:rPr lang="en-US" smtClean="0"/>
+              <a:rPr lang="en-US"/>
               <a:t>Second level</a:t>
             </a:r>
           </a:p>
           <a:p>
             <a:pPr lvl="2"/>
             <a:r>
-              <a:rPr lang="en-US" smtClean="0"/>
+              <a:rPr lang="en-US"/>
               <a:t>Third level</a:t>
             </a:r>
           </a:p>
           <a:p>
             <a:pPr lvl="3"/>
             <a:r>
-              <a:rPr lang="en-US" smtClean="0"/>
+              <a:rPr lang="en-US"/>
               <a:t>Fourth level</a:t>
             </a:r>
           </a:p>
           <a:p>
             <a:pPr lvl="4"/>
             <a:r>
-              <a:rPr lang="en-US" smtClean="0"/>
+              <a:rPr lang="en-US"/>
               <a:t>Fifth level</a:t>
             </a:r>
-            <a:endParaRPr lang="en-US"/>
           </a:p>
         </p:txBody>
       </p:sp>
@@ -2732,7 +2727,7 @@
           <a:p>
             <a:fld id="{5BCAD085-E8A6-8845-BD4E-CB4CCA059FC4}" type="datetimeFigureOut">
               <a:rPr lang="en-US" smtClean="0"/>
-              <a:t>1/27/13</a:t>
+              <a:t>5/9/2026</a:t>
             </a:fld>
             <a:endParaRPr lang="en-US"/>
           </a:p>
@@ -3091,7 +3086,7 @@
 </file>
 
 <file path=ppt/slides/slide1.xml><?xml version="1.0" encoding="utf-8"?>
-<p:sld xmlns:a="http://schemas.openxmlformats.org/drawingml/2006/main" xmlns:p="http://schemas.openxmlformats.org/presentationml/2006/main" xmlns:r="http://schemas.openxmlformats.org/officeDocument/2006/relationships">
+<p:sld xmlns:a="http://schemas.openxmlformats.org/drawingml/2006/main" xmlns:r="http://schemas.openxmlformats.org/officeDocument/2006/relationships" xmlns:p="http://schemas.openxmlformats.org/presentationml/2006/main">
   <p:cSld>
     <p:bg>
       <p:bgPr>
@@ -3107,7 +3102,14 @@
         <p:cNvGrpSpPr/>
         <p:nvPr/>
       </p:nvGrpSpPr>
-      <p:grpSpPr/>
+      <p:grpSpPr>
+        <a:xfrm>
+          <a:off x="0" y="0"/>
+          <a:ext cx="0" cy="0"/>
+          <a:chOff x="0" y="0"/>
+          <a:chExt cx="0" cy="0"/>
+        </a:xfrm>
+      </p:grpSpPr>
       <p:sp>
         <p:nvSpPr>
           <p:cNvPr id="2" name="Rectangle 1"/>
@@ -3148,6 +3150,7 @@
           <a:lstStyle/>
           <a:p>
             <a:pPr algn="ctr"/>
+            <a:endParaRPr/>
           </a:p>
         </p:txBody>
       </p:sp>
@@ -3259,6 +3262,7 @@
           <a:lstStyle/>
           <a:p>
             <a:pPr algn="ctr"/>
+            <a:endParaRPr/>
           </a:p>
         </p:txBody>
       </p:sp>
@@ -3338,6 +3342,7 @@
           <a:lstStyle/>
           <a:p>
             <a:pPr algn="ctr"/>
+            <a:endParaRPr/>
           </a:p>
         </p:txBody>
       </p:sp>
@@ -3452,6 +3457,7 @@
           <a:lstStyle/>
           <a:p>
             <a:pPr algn="ctr"/>
+            <a:endParaRPr/>
           </a:p>
         </p:txBody>
       </p:sp>
@@ -3566,6 +3572,7 @@
           <a:lstStyle/>
           <a:p>
             <a:pPr algn="ctr"/>
+            <a:endParaRPr/>
           </a:p>
         </p:txBody>
       </p:sp>
@@ -3680,6 +3687,7 @@
           <a:lstStyle/>
           <a:p>
             <a:pPr algn="ctr"/>
+            <a:endParaRPr/>
           </a:p>
         </p:txBody>
       </p:sp>
@@ -3795,7 +3803,7 @@
 </file>
 
 <file path=ppt/slides/slide10.xml><?xml version="1.0" encoding="utf-8"?>
-<p:sld xmlns:a="http://schemas.openxmlformats.org/drawingml/2006/main" xmlns:p="http://schemas.openxmlformats.org/presentationml/2006/main" xmlns:r="http://schemas.openxmlformats.org/officeDocument/2006/relationships">
+<p:sld xmlns:a="http://schemas.openxmlformats.org/drawingml/2006/main" xmlns:r="http://schemas.openxmlformats.org/officeDocument/2006/relationships" xmlns:p="http://schemas.openxmlformats.org/presentationml/2006/main">
   <p:cSld>
     <p:bg>
       <p:bgPr>
@@ -3811,7 +3819,14 @@
         <p:cNvGrpSpPr/>
         <p:nvPr/>
       </p:nvGrpSpPr>
-      <p:grpSpPr/>
+      <p:grpSpPr>
+        <a:xfrm>
+          <a:off x="0" y="0"/>
+          <a:ext cx="0" cy="0"/>
+          <a:chOff x="0" y="0"/>
+          <a:chExt cx="0" cy="0"/>
+        </a:xfrm>
+      </p:grpSpPr>
       <p:sp>
         <p:nvSpPr>
           <p:cNvPr id="2" name="Rectangle 1"/>
@@ -3852,6 +3867,7 @@
           <a:lstStyle/>
           <a:p>
             <a:pPr algn="ctr"/>
+            <a:endParaRPr/>
           </a:p>
         </p:txBody>
       </p:sp>
@@ -3963,6 +3979,7 @@
           <a:lstStyle/>
           <a:p>
             <a:pPr algn="ctr"/>
+            <a:endParaRPr/>
           </a:p>
         </p:txBody>
       </p:sp>
@@ -4008,6 +4025,7 @@
           <a:lstStyle/>
           <a:p>
             <a:pPr algn="ctr"/>
+            <a:endParaRPr/>
           </a:p>
         </p:txBody>
       </p:sp>
@@ -4051,6 +4069,7 @@
           <a:lstStyle/>
           <a:p>
             <a:pPr algn="ctr"/>
+            <a:endParaRPr/>
           </a:p>
         </p:txBody>
       </p:sp>
@@ -4164,6 +4183,7 @@
           <a:lstStyle/>
           <a:p>
             <a:pPr algn="ctr"/>
+            <a:endParaRPr/>
           </a:p>
         </p:txBody>
       </p:sp>
@@ -4207,6 +4227,7 @@
           <a:lstStyle/>
           <a:p>
             <a:pPr algn="ctr"/>
+            <a:endParaRPr/>
           </a:p>
         </p:txBody>
       </p:sp>
@@ -4320,6 +4341,7 @@
           <a:lstStyle/>
           <a:p>
             <a:pPr algn="ctr"/>
+            <a:endParaRPr/>
           </a:p>
         </p:txBody>
       </p:sp>
@@ -4363,6 +4385,7 @@
           <a:lstStyle/>
           <a:p>
             <a:pPr algn="ctr"/>
+            <a:endParaRPr/>
           </a:p>
         </p:txBody>
       </p:sp>
@@ -4476,6 +4499,7 @@
           <a:lstStyle/>
           <a:p>
             <a:pPr algn="ctr"/>
+            <a:endParaRPr/>
           </a:p>
         </p:txBody>
       </p:sp>
@@ -4519,6 +4543,7 @@
           <a:lstStyle/>
           <a:p>
             <a:pPr algn="ctr"/>
+            <a:endParaRPr/>
           </a:p>
         </p:txBody>
       </p:sp>
@@ -4599,7 +4624,7 @@
 </file>
 
 <file path=ppt/slides/slide11.xml><?xml version="1.0" encoding="utf-8"?>
-<p:sld xmlns:a="http://schemas.openxmlformats.org/drawingml/2006/main" xmlns:p="http://schemas.openxmlformats.org/presentationml/2006/main" xmlns:r="http://schemas.openxmlformats.org/officeDocument/2006/relationships">
+<p:sld xmlns:a="http://schemas.openxmlformats.org/drawingml/2006/main" xmlns:r="http://schemas.openxmlformats.org/officeDocument/2006/relationships" xmlns:p="http://schemas.openxmlformats.org/presentationml/2006/main">
   <p:cSld>
     <p:bg>
       <p:bgPr>
@@ -4615,7 +4640,14 @@
         <p:cNvGrpSpPr/>
         <p:nvPr/>
       </p:nvGrpSpPr>
-      <p:grpSpPr/>
+      <p:grpSpPr>
+        <a:xfrm>
+          <a:off x="0" y="0"/>
+          <a:ext cx="0" cy="0"/>
+          <a:chOff x="0" y="0"/>
+          <a:chExt cx="0" cy="0"/>
+        </a:xfrm>
+      </p:grpSpPr>
       <p:sp>
         <p:nvSpPr>
           <p:cNvPr id="2" name="Rectangle 1"/>
@@ -4656,6 +4688,7 @@
           <a:lstStyle/>
           <a:p>
             <a:pPr algn="ctr"/>
+            <a:endParaRPr/>
           </a:p>
         </p:txBody>
       </p:sp>
@@ -4767,6 +4800,7 @@
           <a:lstStyle/>
           <a:p>
             <a:pPr algn="ctr"/>
+            <a:endParaRPr/>
           </a:p>
         </p:txBody>
       </p:sp>
@@ -4812,6 +4846,7 @@
           <a:lstStyle/>
           <a:p>
             <a:pPr algn="ctr"/>
+            <a:endParaRPr/>
           </a:p>
         </p:txBody>
       </p:sp>
@@ -4855,6 +4890,7 @@
           <a:lstStyle/>
           <a:p>
             <a:pPr algn="ctr"/>
+            <a:endParaRPr/>
           </a:p>
         </p:txBody>
       </p:sp>
@@ -4882,7 +4918,7 @@
           <a:p>
             <a:pPr algn="ctr"/>
             <a:r>
-              <a:rPr sz="3000" b="1" i="0">
+              <a:rPr sz="3000" b="1" i="0" dirty="0">
                 <a:solidFill>
                   <a:srgbClr val="FFC844"/>
                 </a:solidFill>
@@ -4973,7 +5009,7 @@
 </file>
 
 <file path=ppt/slides/slide12.xml><?xml version="1.0" encoding="utf-8"?>
-<p:sld xmlns:a="http://schemas.openxmlformats.org/drawingml/2006/main" xmlns:p="http://schemas.openxmlformats.org/presentationml/2006/main" xmlns:r="http://schemas.openxmlformats.org/officeDocument/2006/relationships">
+<p:sld xmlns:a="http://schemas.openxmlformats.org/drawingml/2006/main" xmlns:r="http://schemas.openxmlformats.org/officeDocument/2006/relationships" xmlns:p="http://schemas.openxmlformats.org/presentationml/2006/main">
   <p:cSld>
     <p:bg>
       <p:bgPr>
@@ -4989,7 +5025,14 @@
         <p:cNvGrpSpPr/>
         <p:nvPr/>
       </p:nvGrpSpPr>
-      <p:grpSpPr/>
+      <p:grpSpPr>
+        <a:xfrm>
+          <a:off x="0" y="0"/>
+          <a:ext cx="0" cy="0"/>
+          <a:chOff x="0" y="0"/>
+          <a:chExt cx="0" cy="0"/>
+        </a:xfrm>
+      </p:grpSpPr>
       <p:sp>
         <p:nvSpPr>
           <p:cNvPr id="2" name="Rectangle 1"/>
@@ -5030,6 +5073,7 @@
           <a:lstStyle/>
           <a:p>
             <a:pPr algn="ctr"/>
+            <a:endParaRPr/>
           </a:p>
         </p:txBody>
       </p:sp>
@@ -5141,6 +5185,7 @@
           <a:lstStyle/>
           <a:p>
             <a:pPr algn="ctr"/>
+            <a:endParaRPr/>
           </a:p>
         </p:txBody>
       </p:sp>
@@ -5186,6 +5231,7 @@
           <a:lstStyle/>
           <a:p>
             <a:pPr algn="ctr"/>
+            <a:endParaRPr/>
           </a:p>
         </p:txBody>
       </p:sp>
@@ -5300,6 +5346,7 @@
           <a:lstStyle/>
           <a:p>
             <a:pPr algn="ctr"/>
+            <a:endParaRPr/>
           </a:p>
         </p:txBody>
       </p:sp>
@@ -5414,6 +5461,7 @@
           <a:lstStyle/>
           <a:p>
             <a:pPr algn="ctr"/>
+            <a:endParaRPr/>
           </a:p>
         </p:txBody>
       </p:sp>
@@ -5528,6 +5576,7 @@
           <a:lstStyle/>
           <a:p>
             <a:pPr algn="ctr"/>
+            <a:endParaRPr/>
           </a:p>
         </p:txBody>
       </p:sp>
@@ -5641,6 +5690,7 @@
           <a:lstStyle/>
           <a:p>
             <a:pPr algn="ctr"/>
+            <a:endParaRPr/>
           </a:p>
         </p:txBody>
       </p:sp>
@@ -5718,6 +5768,7 @@
           <a:lstStyle/>
           <a:p>
             <a:pPr algn="ctr"/>
+            <a:endParaRPr/>
           </a:p>
         </p:txBody>
       </p:sp>
@@ -5761,6 +5812,7 @@
           <a:lstStyle/>
           <a:p>
             <a:pPr algn="ctr"/>
+            <a:endParaRPr/>
           </a:p>
         </p:txBody>
       </p:sp>
@@ -5872,6 +5924,7 @@
           <a:lstStyle/>
           <a:p>
             <a:pPr algn="ctr"/>
+            <a:endParaRPr/>
           </a:p>
         </p:txBody>
       </p:sp>
@@ -5983,6 +6036,7 @@
           <a:lstStyle/>
           <a:p>
             <a:pPr algn="ctr"/>
+            <a:endParaRPr/>
           </a:p>
         </p:txBody>
       </p:sp>
@@ -6094,6 +6148,7 @@
           <a:lstStyle/>
           <a:p>
             <a:pPr algn="ctr"/>
+            <a:endParaRPr/>
           </a:p>
         </p:txBody>
       </p:sp>
@@ -6174,7 +6229,7 @@
 </file>
 
 <file path=ppt/slides/slide13.xml><?xml version="1.0" encoding="utf-8"?>
-<p:sld xmlns:a="http://schemas.openxmlformats.org/drawingml/2006/main" xmlns:p="http://schemas.openxmlformats.org/presentationml/2006/main" xmlns:r="http://schemas.openxmlformats.org/officeDocument/2006/relationships">
+<p:sld xmlns:a="http://schemas.openxmlformats.org/drawingml/2006/main" xmlns:r="http://schemas.openxmlformats.org/officeDocument/2006/relationships" xmlns:p="http://schemas.openxmlformats.org/presentationml/2006/main">
   <p:cSld>
     <p:bg>
       <p:bgPr>
@@ -6190,7 +6245,14 @@
         <p:cNvGrpSpPr/>
         <p:nvPr/>
       </p:nvGrpSpPr>
-      <p:grpSpPr/>
+      <p:grpSpPr>
+        <a:xfrm>
+          <a:off x="0" y="0"/>
+          <a:ext cx="0" cy="0"/>
+          <a:chOff x="0" y="0"/>
+          <a:chExt cx="0" cy="0"/>
+        </a:xfrm>
+      </p:grpSpPr>
       <p:sp>
         <p:nvSpPr>
           <p:cNvPr id="2" name="Rectangle 1"/>
@@ -6231,6 +6293,7 @@
           <a:lstStyle/>
           <a:p>
             <a:pPr algn="ctr"/>
+            <a:endParaRPr/>
           </a:p>
         </p:txBody>
       </p:sp>
@@ -6342,6 +6405,7 @@
           <a:lstStyle/>
           <a:p>
             <a:pPr algn="ctr"/>
+            <a:endParaRPr/>
           </a:p>
         </p:txBody>
       </p:sp>
@@ -6387,6 +6451,7 @@
           <a:lstStyle/>
           <a:p>
             <a:pPr algn="ctr"/>
+            <a:endParaRPr/>
           </a:p>
         </p:txBody>
       </p:sp>
@@ -6532,6 +6597,7 @@
           <a:lstStyle/>
           <a:p>
             <a:pPr algn="ctr"/>
+            <a:endParaRPr/>
           </a:p>
         </p:txBody>
       </p:sp>
@@ -6677,6 +6743,7 @@
           <a:lstStyle/>
           <a:p>
             <a:pPr algn="ctr"/>
+            <a:endParaRPr/>
           </a:p>
         </p:txBody>
       </p:sp>
@@ -6822,6 +6889,7 @@
           <a:lstStyle/>
           <a:p>
             <a:pPr algn="ctr"/>
+            <a:endParaRPr/>
           </a:p>
         </p:txBody>
       </p:sp>
@@ -6967,6 +7035,7 @@
           <a:lstStyle/>
           <a:p>
             <a:pPr algn="ctr"/>
+            <a:endParaRPr/>
           </a:p>
         </p:txBody>
       </p:sp>
@@ -7112,6 +7181,7 @@
           <a:lstStyle/>
           <a:p>
             <a:pPr algn="ctr"/>
+            <a:endParaRPr/>
           </a:p>
         </p:txBody>
       </p:sp>
@@ -7257,6 +7327,7 @@
           <a:lstStyle/>
           <a:p>
             <a:pPr algn="ctr"/>
+            <a:endParaRPr/>
           </a:p>
         </p:txBody>
       </p:sp>
@@ -7402,6 +7473,7 @@
           <a:lstStyle/>
           <a:p>
             <a:pPr algn="ctr"/>
+            <a:endParaRPr/>
           </a:p>
         </p:txBody>
       </p:sp>
@@ -7448,7 +7520,7 @@
 </file>
 
 <file path=ppt/slides/slide2.xml><?xml version="1.0" encoding="utf-8"?>
-<p:sld xmlns:a="http://schemas.openxmlformats.org/drawingml/2006/main" xmlns:p="http://schemas.openxmlformats.org/presentationml/2006/main" xmlns:r="http://schemas.openxmlformats.org/officeDocument/2006/relationships">
+<p:sld xmlns:a="http://schemas.openxmlformats.org/drawingml/2006/main" xmlns:r="http://schemas.openxmlformats.org/officeDocument/2006/relationships" xmlns:p="http://schemas.openxmlformats.org/presentationml/2006/main">
   <p:cSld>
     <p:bg>
       <p:bgPr>
@@ -7464,7 +7536,14 @@
         <p:cNvGrpSpPr/>
         <p:nvPr/>
       </p:nvGrpSpPr>
-      <p:grpSpPr/>
+      <p:grpSpPr>
+        <a:xfrm>
+          <a:off x="0" y="0"/>
+          <a:ext cx="0" cy="0"/>
+          <a:chOff x="0" y="0"/>
+          <a:chExt cx="0" cy="0"/>
+        </a:xfrm>
+      </p:grpSpPr>
       <p:sp>
         <p:nvSpPr>
           <p:cNvPr id="2" name="Rectangle 1"/>
@@ -7505,6 +7584,7 @@
           <a:lstStyle/>
           <a:p>
             <a:pPr algn="ctr"/>
+            <a:endParaRPr/>
           </a:p>
         </p:txBody>
       </p:sp>
@@ -7616,6 +7696,7 @@
           <a:lstStyle/>
           <a:p>
             <a:pPr algn="ctr"/>
+            <a:endParaRPr/>
           </a:p>
         </p:txBody>
       </p:sp>
@@ -7661,6 +7742,7 @@
           <a:lstStyle/>
           <a:p>
             <a:pPr algn="ctr"/>
+            <a:endParaRPr/>
           </a:p>
         </p:txBody>
       </p:sp>
@@ -7704,6 +7786,7 @@
           <a:lstStyle/>
           <a:p>
             <a:pPr algn="ctr"/>
+            <a:endParaRPr/>
           </a:p>
         </p:txBody>
       </p:sp>
@@ -7953,6 +8036,7 @@
           <a:lstStyle/>
           <a:p>
             <a:pPr algn="ctr"/>
+            <a:endParaRPr/>
           </a:p>
         </p:txBody>
       </p:sp>
@@ -7996,6 +8080,7 @@
           <a:lstStyle/>
           <a:p>
             <a:pPr algn="ctr"/>
+            <a:endParaRPr/>
           </a:p>
         </p:txBody>
       </p:sp>
@@ -8243,6 +8328,7 @@
           <a:lstStyle/>
           <a:p>
             <a:pPr algn="ctr"/>
+            <a:endParaRPr/>
           </a:p>
         </p:txBody>
       </p:sp>
@@ -8288,6 +8374,7 @@
           <a:lstStyle/>
           <a:p>
             <a:pPr algn="ctr"/>
+            <a:endParaRPr/>
           </a:p>
         </p:txBody>
       </p:sp>
@@ -8367,6 +8454,7 @@
           <a:lstStyle/>
           <a:p>
             <a:pPr algn="ctr"/>
+            <a:endParaRPr/>
           </a:p>
         </p:txBody>
       </p:sp>
@@ -8480,6 +8568,7 @@
           <a:lstStyle/>
           <a:p>
             <a:pPr algn="ctr"/>
+            <a:endParaRPr/>
           </a:p>
         </p:txBody>
       </p:sp>
@@ -8593,6 +8682,7 @@
           <a:lstStyle/>
           <a:p>
             <a:pPr algn="ctr"/>
+            <a:endParaRPr/>
           </a:p>
         </p:txBody>
       </p:sp>
@@ -8706,6 +8796,7 @@
           <a:lstStyle/>
           <a:p>
             <a:pPr algn="ctr"/>
+            <a:endParaRPr/>
           </a:p>
         </p:txBody>
       </p:sp>
@@ -8786,7 +8877,7 @@
 </file>
 
 <file path=ppt/slides/slide3.xml><?xml version="1.0" encoding="utf-8"?>
-<p:sld xmlns:a="http://schemas.openxmlformats.org/drawingml/2006/main" xmlns:p="http://schemas.openxmlformats.org/presentationml/2006/main" xmlns:r="http://schemas.openxmlformats.org/officeDocument/2006/relationships">
+<p:sld xmlns:a="http://schemas.openxmlformats.org/drawingml/2006/main" xmlns:r="http://schemas.openxmlformats.org/officeDocument/2006/relationships" xmlns:p="http://schemas.openxmlformats.org/presentationml/2006/main">
   <p:cSld>
     <p:bg>
       <p:bgPr>
@@ -8802,7 +8893,14 @@
         <p:cNvGrpSpPr/>
         <p:nvPr/>
       </p:nvGrpSpPr>
-      <p:grpSpPr/>
+      <p:grpSpPr>
+        <a:xfrm>
+          <a:off x="0" y="0"/>
+          <a:ext cx="0" cy="0"/>
+          <a:chOff x="0" y="0"/>
+          <a:chExt cx="0" cy="0"/>
+        </a:xfrm>
+      </p:grpSpPr>
       <p:sp>
         <p:nvSpPr>
           <p:cNvPr id="2" name="Rectangle 1"/>
@@ -8843,6 +8941,7 @@
           <a:lstStyle/>
           <a:p>
             <a:pPr algn="ctr"/>
+            <a:endParaRPr/>
           </a:p>
         </p:txBody>
       </p:sp>
@@ -8954,6 +9053,7 @@
           <a:lstStyle/>
           <a:p>
             <a:pPr algn="ctr"/>
+            <a:endParaRPr/>
           </a:p>
         </p:txBody>
       </p:sp>
@@ -8999,6 +9099,7 @@
           <a:lstStyle/>
           <a:p>
             <a:pPr algn="ctr"/>
+            <a:endParaRPr/>
           </a:p>
         </p:txBody>
       </p:sp>
@@ -9042,6 +9143,7 @@
           <a:lstStyle/>
           <a:p>
             <a:pPr algn="ctr"/>
+            <a:endParaRPr/>
           </a:p>
         </p:txBody>
       </p:sp>
@@ -9393,6 +9495,7 @@
           <a:lstStyle/>
           <a:p>
             <a:pPr algn="ctr"/>
+            <a:endParaRPr/>
           </a:p>
         </p:txBody>
       </p:sp>
@@ -9436,6 +9539,7 @@
           <a:lstStyle/>
           <a:p>
             <a:pPr algn="ctr"/>
+            <a:endParaRPr/>
           </a:p>
         </p:txBody>
       </p:sp>
@@ -9651,6 +9755,7 @@
           <a:lstStyle/>
           <a:p>
             <a:pPr algn="ctr"/>
+            <a:endParaRPr/>
           </a:p>
         </p:txBody>
       </p:sp>
@@ -9694,6 +9799,7 @@
           <a:lstStyle/>
           <a:p>
             <a:pPr algn="ctr"/>
+            <a:endParaRPr/>
           </a:p>
         </p:txBody>
       </p:sp>
@@ -9943,6 +10049,7 @@
           <a:lstStyle/>
           <a:p>
             <a:pPr algn="ctr"/>
+            <a:endParaRPr/>
           </a:p>
         </p:txBody>
       </p:sp>
@@ -9986,6 +10093,7 @@
           <a:lstStyle/>
           <a:p>
             <a:pPr algn="ctr"/>
+            <a:endParaRPr/>
           </a:p>
         </p:txBody>
       </p:sp>
@@ -10270,7 +10378,7 @@
 </file>
 
 <file path=ppt/slides/slide4.xml><?xml version="1.0" encoding="utf-8"?>
-<p:sld xmlns:a="http://schemas.openxmlformats.org/drawingml/2006/main" xmlns:p="http://schemas.openxmlformats.org/presentationml/2006/main" xmlns:r="http://schemas.openxmlformats.org/officeDocument/2006/relationships">
+<p:sld xmlns:a="http://schemas.openxmlformats.org/drawingml/2006/main" xmlns:r="http://schemas.openxmlformats.org/officeDocument/2006/relationships" xmlns:p="http://schemas.openxmlformats.org/presentationml/2006/main">
   <p:cSld>
     <p:bg>
       <p:bgPr>
@@ -10286,7 +10394,14 @@
         <p:cNvGrpSpPr/>
         <p:nvPr/>
       </p:nvGrpSpPr>
-      <p:grpSpPr/>
+      <p:grpSpPr>
+        <a:xfrm>
+          <a:off x="0" y="0"/>
+          <a:ext cx="0" cy="0"/>
+          <a:chOff x="0" y="0"/>
+          <a:chExt cx="0" cy="0"/>
+        </a:xfrm>
+      </p:grpSpPr>
       <p:sp>
         <p:nvSpPr>
           <p:cNvPr id="2" name="Rectangle 1"/>
@@ -10327,6 +10442,7 @@
           <a:lstStyle/>
           <a:p>
             <a:pPr algn="ctr"/>
+            <a:endParaRPr/>
           </a:p>
         </p:txBody>
       </p:sp>
@@ -10438,6 +10554,7 @@
           <a:lstStyle/>
           <a:p>
             <a:pPr algn="ctr"/>
+            <a:endParaRPr/>
           </a:p>
         </p:txBody>
       </p:sp>
@@ -10483,6 +10600,7 @@
           <a:lstStyle/>
           <a:p>
             <a:pPr algn="ctr"/>
+            <a:endParaRPr/>
           </a:p>
         </p:txBody>
       </p:sp>
@@ -10526,6 +10644,7 @@
           <a:lstStyle/>
           <a:p>
             <a:pPr algn="ctr"/>
+            <a:endParaRPr/>
           </a:p>
         </p:txBody>
       </p:sp>
@@ -10741,6 +10860,7 @@
           <a:lstStyle/>
           <a:p>
             <a:pPr algn="ctr"/>
+            <a:endParaRPr/>
           </a:p>
         </p:txBody>
       </p:sp>
@@ -10784,6 +10904,7 @@
           <a:lstStyle/>
           <a:p>
             <a:pPr algn="ctr"/>
+            <a:endParaRPr/>
           </a:p>
         </p:txBody>
       </p:sp>
@@ -10999,6 +11120,7 @@
           <a:lstStyle/>
           <a:p>
             <a:pPr algn="ctr"/>
+            <a:endParaRPr/>
           </a:p>
         </p:txBody>
       </p:sp>
@@ -11280,6 +11402,7 @@
           <a:lstStyle/>
           <a:p>
             <a:pPr algn="ctr"/>
+            <a:endParaRPr/>
           </a:p>
         </p:txBody>
       </p:sp>
@@ -11323,6 +11446,7 @@
           <a:lstStyle/>
           <a:p>
             <a:pPr algn="ctr"/>
+            <a:endParaRPr/>
           </a:p>
         </p:txBody>
       </p:sp>
@@ -11570,6 +11694,7 @@
           <a:lstStyle/>
           <a:p>
             <a:pPr algn="ctr"/>
+            <a:endParaRPr/>
           </a:p>
         </p:txBody>
       </p:sp>
@@ -11817,6 +11942,7 @@
           <a:lstStyle/>
           <a:p>
             <a:pPr algn="ctr"/>
+            <a:endParaRPr/>
           </a:p>
         </p:txBody>
       </p:sp>
@@ -12033,7 +12159,7 @@
 </file>
 
 <file path=ppt/slides/slide5.xml><?xml version="1.0" encoding="utf-8"?>
-<p:sld xmlns:a="http://schemas.openxmlformats.org/drawingml/2006/main" xmlns:p="http://schemas.openxmlformats.org/presentationml/2006/main" xmlns:r="http://schemas.openxmlformats.org/officeDocument/2006/relationships">
+<p:sld xmlns:a="http://schemas.openxmlformats.org/drawingml/2006/main" xmlns:r="http://schemas.openxmlformats.org/officeDocument/2006/relationships" xmlns:p="http://schemas.openxmlformats.org/presentationml/2006/main">
   <p:cSld>
     <p:bg>
       <p:bgPr>
@@ -12049,7 +12175,14 @@
         <p:cNvGrpSpPr/>
         <p:nvPr/>
       </p:nvGrpSpPr>
-      <p:grpSpPr/>
+      <p:grpSpPr>
+        <a:xfrm>
+          <a:off x="0" y="0"/>
+          <a:ext cx="0" cy="0"/>
+          <a:chOff x="0" y="0"/>
+          <a:chExt cx="0" cy="0"/>
+        </a:xfrm>
+      </p:grpSpPr>
       <p:sp>
         <p:nvSpPr>
           <p:cNvPr id="2" name="Rectangle 1"/>
@@ -12090,6 +12223,7 @@
           <a:lstStyle/>
           <a:p>
             <a:pPr algn="ctr"/>
+            <a:endParaRPr/>
           </a:p>
         </p:txBody>
       </p:sp>
@@ -12201,6 +12335,7 @@
           <a:lstStyle/>
           <a:p>
             <a:pPr algn="ctr"/>
+            <a:endParaRPr/>
           </a:p>
         </p:txBody>
       </p:sp>
@@ -12246,6 +12381,7 @@
           <a:lstStyle/>
           <a:p>
             <a:pPr algn="ctr"/>
+            <a:endParaRPr/>
           </a:p>
         </p:txBody>
       </p:sp>
@@ -12289,6 +12425,7 @@
           <a:lstStyle/>
           <a:p>
             <a:pPr algn="ctr"/>
+            <a:endParaRPr/>
           </a:p>
         </p:txBody>
       </p:sp>
@@ -12401,6 +12538,7 @@
           <a:lstStyle/>
           <a:p>
             <a:pPr algn="ctr"/>
+            <a:endParaRPr/>
           </a:p>
         </p:txBody>
       </p:sp>
@@ -12512,6 +12650,7 @@
           <a:lstStyle/>
           <a:p>
             <a:pPr algn="ctr"/>
+            <a:endParaRPr/>
           </a:p>
         </p:txBody>
       </p:sp>
@@ -12591,6 +12730,7 @@
           <a:lstStyle/>
           <a:p>
             <a:pPr algn="ctr"/>
+            <a:endParaRPr/>
           </a:p>
         </p:txBody>
       </p:sp>
@@ -12634,6 +12774,7 @@
           <a:lstStyle/>
           <a:p>
             <a:pPr algn="ctr"/>
+            <a:endParaRPr/>
           </a:p>
         </p:txBody>
       </p:sp>
@@ -12746,6 +12887,7 @@
           <a:lstStyle/>
           <a:p>
             <a:pPr algn="ctr"/>
+            <a:endParaRPr/>
           </a:p>
         </p:txBody>
       </p:sp>
@@ -12857,6 +12999,7 @@
           <a:lstStyle/>
           <a:p>
             <a:pPr algn="ctr"/>
+            <a:endParaRPr/>
           </a:p>
         </p:txBody>
       </p:sp>
@@ -12936,6 +13079,7 @@
           <a:lstStyle/>
           <a:p>
             <a:pPr algn="ctr"/>
+            <a:endParaRPr/>
           </a:p>
         </p:txBody>
       </p:sp>
@@ -12979,6 +13123,7 @@
           <a:lstStyle/>
           <a:p>
             <a:pPr algn="ctr"/>
+            <a:endParaRPr/>
           </a:p>
         </p:txBody>
       </p:sp>
@@ -13091,6 +13236,7 @@
           <a:lstStyle/>
           <a:p>
             <a:pPr algn="ctr"/>
+            <a:endParaRPr/>
           </a:p>
         </p:txBody>
       </p:sp>
@@ -13202,6 +13348,7 @@
           <a:lstStyle/>
           <a:p>
             <a:pPr algn="ctr"/>
+            <a:endParaRPr/>
           </a:p>
         </p:txBody>
       </p:sp>
@@ -13281,6 +13428,7 @@
           <a:lstStyle/>
           <a:p>
             <a:pPr algn="ctr"/>
+            <a:endParaRPr/>
           </a:p>
         </p:txBody>
       </p:sp>
@@ -13324,6 +13472,7 @@
           <a:lstStyle/>
           <a:p>
             <a:pPr algn="ctr"/>
+            <a:endParaRPr/>
           </a:p>
         </p:txBody>
       </p:sp>
@@ -13436,6 +13585,7 @@
           <a:lstStyle/>
           <a:p>
             <a:pPr algn="ctr"/>
+            <a:endParaRPr/>
           </a:p>
         </p:txBody>
       </p:sp>
@@ -13547,6 +13697,7 @@
           <a:lstStyle/>
           <a:p>
             <a:pPr algn="ctr"/>
+            <a:endParaRPr/>
           </a:p>
         </p:txBody>
       </p:sp>
@@ -13626,6 +13777,7 @@
           <a:lstStyle/>
           <a:p>
             <a:pPr algn="ctr"/>
+            <a:endParaRPr/>
           </a:p>
         </p:txBody>
       </p:sp>
@@ -13669,6 +13821,7 @@
           <a:lstStyle/>
           <a:p>
             <a:pPr algn="ctr"/>
+            <a:endParaRPr/>
           </a:p>
         </p:txBody>
       </p:sp>
@@ -13781,6 +13934,7 @@
           <a:lstStyle/>
           <a:p>
             <a:pPr algn="ctr"/>
+            <a:endParaRPr/>
           </a:p>
         </p:txBody>
       </p:sp>
@@ -13892,6 +14046,7 @@
           <a:lstStyle/>
           <a:p>
             <a:pPr algn="ctr"/>
+            <a:endParaRPr/>
           </a:p>
         </p:txBody>
       </p:sp>
@@ -13938,7 +14093,7 @@
 </file>
 
 <file path=ppt/slides/slide6.xml><?xml version="1.0" encoding="utf-8"?>
-<p:sld xmlns:a="http://schemas.openxmlformats.org/drawingml/2006/main" xmlns:p="http://schemas.openxmlformats.org/presentationml/2006/main" xmlns:r="http://schemas.openxmlformats.org/officeDocument/2006/relationships">
+<p:sld xmlns:a="http://schemas.openxmlformats.org/drawingml/2006/main" xmlns:r="http://schemas.openxmlformats.org/officeDocument/2006/relationships" xmlns:p="http://schemas.openxmlformats.org/presentationml/2006/main">
   <p:cSld>
     <p:bg>
       <p:bgPr>
@@ -13954,7 +14109,14 @@
         <p:cNvGrpSpPr/>
         <p:nvPr/>
       </p:nvGrpSpPr>
-      <p:grpSpPr/>
+      <p:grpSpPr>
+        <a:xfrm>
+          <a:off x="0" y="0"/>
+          <a:ext cx="0" cy="0"/>
+          <a:chOff x="0" y="0"/>
+          <a:chExt cx="0" cy="0"/>
+        </a:xfrm>
+      </p:grpSpPr>
       <p:sp>
         <p:nvSpPr>
           <p:cNvPr id="2" name="Rectangle 1"/>
@@ -13995,6 +14157,7 @@
           <a:lstStyle/>
           <a:p>
             <a:pPr algn="ctr"/>
+            <a:endParaRPr/>
           </a:p>
         </p:txBody>
       </p:sp>
@@ -14106,6 +14269,7 @@
           <a:lstStyle/>
           <a:p>
             <a:pPr algn="ctr"/>
+            <a:endParaRPr/>
           </a:p>
         </p:txBody>
       </p:sp>
@@ -14117,7 +14281,7 @@
         </p:nvSpPr>
         <p:spPr>
           <a:xfrm>
-            <a:off x="274320" y="1444752"/>
+            <a:off x="-274320" y="1463040"/>
             <a:ext cx="1645920" cy="438912"/>
           </a:xfrm>
           <a:prstGeom prst="rect">
@@ -14183,6 +14347,7 @@
           <a:lstStyle/>
           <a:p>
             <a:pPr algn="ctr"/>
+            <a:endParaRPr/>
           </a:p>
         </p:txBody>
       </p:sp>
@@ -14226,6 +14391,7 @@
           <a:lstStyle/>
           <a:p>
             <a:pPr algn="ctr"/>
+            <a:endParaRPr/>
           </a:p>
         </p:txBody>
       </p:sp>
@@ -14271,7 +14437,7 @@
         </p:nvSpPr>
         <p:spPr>
           <a:xfrm>
-            <a:off x="274320" y="2103120"/>
+            <a:off x="-274320" y="2121408"/>
             <a:ext cx="1645920" cy="438912"/>
           </a:xfrm>
           <a:prstGeom prst="rect">
@@ -14287,7 +14453,7 @@
           <a:p>
             <a:pPr algn="r"/>
             <a:r>
-              <a:rPr sz="1300" b="0" i="0">
+              <a:rPr sz="1300" b="0" i="0" dirty="0">
                 <a:solidFill>
                   <a:srgbClr val="8888AA"/>
                 </a:solidFill>
@@ -14337,6 +14503,7 @@
           <a:lstStyle/>
           <a:p>
             <a:pPr algn="ctr"/>
+            <a:endParaRPr/>
           </a:p>
         </p:txBody>
       </p:sp>
@@ -14380,6 +14547,7 @@
           <a:lstStyle/>
           <a:p>
             <a:pPr algn="ctr"/>
+            <a:endParaRPr/>
           </a:p>
         </p:txBody>
       </p:sp>
@@ -14425,7 +14593,7 @@
         </p:nvSpPr>
         <p:spPr>
           <a:xfrm>
-            <a:off x="274320" y="2761488"/>
+            <a:off x="-365760" y="2798064"/>
             <a:ext cx="1645920" cy="438912"/>
           </a:xfrm>
           <a:prstGeom prst="rect">
@@ -14491,6 +14659,7 @@
           <a:lstStyle/>
           <a:p>
             <a:pPr algn="ctr"/>
+            <a:endParaRPr/>
           </a:p>
         </p:txBody>
       </p:sp>
@@ -14534,6 +14703,7 @@
           <a:lstStyle/>
           <a:p>
             <a:pPr algn="ctr"/>
+            <a:endParaRPr/>
           </a:p>
         </p:txBody>
       </p:sp>
@@ -14579,7 +14749,7 @@
         </p:nvSpPr>
         <p:spPr>
           <a:xfrm>
-            <a:off x="274320" y="3419856"/>
+            <a:off x="-225988" y="3456432"/>
             <a:ext cx="1645920" cy="438912"/>
           </a:xfrm>
           <a:prstGeom prst="rect">
@@ -14645,6 +14815,7 @@
           <a:lstStyle/>
           <a:p>
             <a:pPr algn="ctr"/>
+            <a:endParaRPr/>
           </a:p>
         </p:txBody>
       </p:sp>
@@ -14688,6 +14859,7 @@
           <a:lstStyle/>
           <a:p>
             <a:pPr algn="ctr"/>
+            <a:endParaRPr/>
           </a:p>
         </p:txBody>
       </p:sp>
@@ -14733,7 +14905,7 @@
         </p:nvSpPr>
         <p:spPr>
           <a:xfrm>
-            <a:off x="274320" y="4078224"/>
+            <a:off x="-365760" y="4114800"/>
             <a:ext cx="1645920" cy="438912"/>
           </a:xfrm>
           <a:prstGeom prst="rect">
@@ -14799,6 +14971,7 @@
           <a:lstStyle/>
           <a:p>
             <a:pPr algn="ctr"/>
+            <a:endParaRPr/>
           </a:p>
         </p:txBody>
       </p:sp>
@@ -14842,6 +15015,7 @@
           <a:lstStyle/>
           <a:p>
             <a:pPr algn="ctr"/>
+            <a:endParaRPr/>
           </a:p>
         </p:txBody>
       </p:sp>
@@ -14887,7 +15061,7 @@
         </p:nvSpPr>
         <p:spPr>
           <a:xfrm>
-            <a:off x="274320" y="4736592"/>
+            <a:off x="-320040" y="4754880"/>
             <a:ext cx="1645920" cy="438912"/>
           </a:xfrm>
           <a:prstGeom prst="rect">
@@ -14953,6 +15127,7 @@
           <a:lstStyle/>
           <a:p>
             <a:pPr algn="ctr"/>
+            <a:endParaRPr/>
           </a:p>
         </p:txBody>
       </p:sp>
@@ -14996,6 +15171,7 @@
           <a:lstStyle/>
           <a:p>
             <a:pPr algn="ctr"/>
+            <a:endParaRPr/>
           </a:p>
         </p:txBody>
       </p:sp>
@@ -15041,7 +15217,7 @@
         </p:nvSpPr>
         <p:spPr>
           <a:xfrm>
-            <a:off x="274320" y="5394960"/>
+            <a:off x="-274320" y="5404104"/>
             <a:ext cx="1645920" cy="438912"/>
           </a:xfrm>
           <a:prstGeom prst="rect">
@@ -15107,6 +15283,7 @@
           <a:lstStyle/>
           <a:p>
             <a:pPr algn="ctr"/>
+            <a:endParaRPr/>
           </a:p>
         </p:txBody>
       </p:sp>
@@ -15150,6 +15327,7 @@
           <a:lstStyle/>
           <a:p>
             <a:pPr algn="ctr"/>
+            <a:endParaRPr/>
           </a:p>
         </p:txBody>
       </p:sp>
@@ -15227,6 +15405,7 @@
           <a:lstStyle/>
           <a:p>
             <a:pPr algn="ctr"/>
+            <a:endParaRPr/>
           </a:p>
         </p:txBody>
       </p:sp>
@@ -15579,7 +15758,7 @@
 </file>
 
 <file path=ppt/slides/slide7.xml><?xml version="1.0" encoding="utf-8"?>
-<p:sld xmlns:a="http://schemas.openxmlformats.org/drawingml/2006/main" xmlns:p="http://schemas.openxmlformats.org/presentationml/2006/main" xmlns:r="http://schemas.openxmlformats.org/officeDocument/2006/relationships">
+<p:sld xmlns:a="http://schemas.openxmlformats.org/drawingml/2006/main" xmlns:r="http://schemas.openxmlformats.org/officeDocument/2006/relationships" xmlns:p="http://schemas.openxmlformats.org/presentationml/2006/main">
   <p:cSld>
     <p:bg>
       <p:bgPr>
@@ -15595,7 +15774,14 @@
         <p:cNvGrpSpPr/>
         <p:nvPr/>
       </p:nvGrpSpPr>
-      <p:grpSpPr/>
+      <p:grpSpPr>
+        <a:xfrm>
+          <a:off x="0" y="0"/>
+          <a:ext cx="0" cy="0"/>
+          <a:chOff x="0" y="0"/>
+          <a:chExt cx="0" cy="0"/>
+        </a:xfrm>
+      </p:grpSpPr>
       <p:sp>
         <p:nvSpPr>
           <p:cNvPr id="2" name="Rectangle 1"/>
@@ -15636,6 +15822,7 @@
           <a:lstStyle/>
           <a:p>
             <a:pPr algn="ctr"/>
+            <a:endParaRPr/>
           </a:p>
         </p:txBody>
       </p:sp>
@@ -15747,6 +15934,7 @@
           <a:lstStyle/>
           <a:p>
             <a:pPr algn="ctr"/>
+            <a:endParaRPr/>
           </a:p>
         </p:txBody>
       </p:sp>
@@ -15790,6 +15978,7 @@
           <a:lstStyle/>
           <a:p>
             <a:pPr algn="ctr"/>
+            <a:endParaRPr/>
           </a:p>
         </p:txBody>
       </p:sp>
@@ -15833,6 +16022,7 @@
           <a:lstStyle/>
           <a:p>
             <a:pPr algn="ctr"/>
+            <a:endParaRPr/>
           </a:p>
         </p:txBody>
       </p:sp>
@@ -15910,6 +16100,7 @@
           <a:lstStyle/>
           <a:p>
             <a:pPr algn="ctr"/>
+            <a:endParaRPr/>
           </a:p>
         </p:txBody>
       </p:sp>
@@ -15987,6 +16178,7 @@
           <a:lstStyle/>
           <a:p>
             <a:pPr algn="ctr"/>
+            <a:endParaRPr/>
           </a:p>
         </p:txBody>
       </p:sp>
@@ -16064,6 +16256,7 @@
           <a:lstStyle/>
           <a:p>
             <a:pPr algn="ctr"/>
+            <a:endParaRPr/>
           </a:p>
         </p:txBody>
       </p:sp>
@@ -16141,6 +16334,7 @@
           <a:lstStyle/>
           <a:p>
             <a:pPr algn="ctr"/>
+            <a:endParaRPr/>
           </a:p>
         </p:txBody>
       </p:sp>
@@ -16218,6 +16412,7 @@
           <a:lstStyle/>
           <a:p>
             <a:pPr algn="ctr"/>
+            <a:endParaRPr/>
           </a:p>
         </p:txBody>
       </p:sp>
@@ -16295,6 +16490,7 @@
           <a:lstStyle/>
           <a:p>
             <a:pPr algn="ctr"/>
+            <a:endParaRPr/>
           </a:p>
         </p:txBody>
       </p:sp>
@@ -16406,6 +16602,7 @@
           <a:lstStyle/>
           <a:p>
             <a:pPr algn="ctr"/>
+            <a:endParaRPr/>
           </a:p>
         </p:txBody>
       </p:sp>
@@ -16483,6 +16680,7 @@
           <a:lstStyle/>
           <a:p>
             <a:pPr algn="ctr"/>
+            <a:endParaRPr/>
           </a:p>
         </p:txBody>
       </p:sp>
@@ -16560,6 +16758,7 @@
           <a:lstStyle/>
           <a:p>
             <a:pPr algn="ctr"/>
+            <a:endParaRPr/>
           </a:p>
         </p:txBody>
       </p:sp>
@@ -16637,6 +16836,7 @@
           <a:lstStyle/>
           <a:p>
             <a:pPr algn="ctr"/>
+            <a:endParaRPr/>
           </a:p>
         </p:txBody>
       </p:sp>
@@ -16714,6 +16914,7 @@
           <a:lstStyle/>
           <a:p>
             <a:pPr algn="ctr"/>
+            <a:endParaRPr/>
           </a:p>
         </p:txBody>
       </p:sp>
@@ -16791,6 +16992,7 @@
           <a:lstStyle/>
           <a:p>
             <a:pPr algn="ctr"/>
+            <a:endParaRPr/>
           </a:p>
         </p:txBody>
       </p:sp>
@@ -16868,6 +17070,7 @@
           <a:lstStyle/>
           <a:p>
             <a:pPr algn="ctr"/>
+            <a:endParaRPr/>
           </a:p>
         </p:txBody>
       </p:sp>
@@ -16945,6 +17148,7 @@
           <a:lstStyle/>
           <a:p>
             <a:pPr algn="ctr"/>
+            <a:endParaRPr/>
           </a:p>
         </p:txBody>
       </p:sp>
@@ -17022,6 +17226,7 @@
           <a:lstStyle/>
           <a:p>
             <a:pPr algn="ctr"/>
+            <a:endParaRPr/>
           </a:p>
         </p:txBody>
       </p:sp>
@@ -17065,6 +17270,7 @@
           <a:lstStyle/>
           <a:p>
             <a:pPr algn="ctr"/>
+            <a:endParaRPr/>
           </a:p>
         </p:txBody>
       </p:sp>
@@ -17108,6 +17314,7 @@
           <a:lstStyle/>
           <a:p>
             <a:pPr algn="ctr"/>
+            <a:endParaRPr/>
           </a:p>
         </p:txBody>
       </p:sp>
@@ -17151,6 +17358,7 @@
           <a:lstStyle/>
           <a:p>
             <a:pPr algn="ctr"/>
+            <a:endParaRPr/>
           </a:p>
         </p:txBody>
       </p:sp>
@@ -17194,6 +17402,7 @@
           <a:lstStyle/>
           <a:p>
             <a:pPr algn="ctr"/>
+            <a:endParaRPr/>
           </a:p>
         </p:txBody>
       </p:sp>
@@ -17237,6 +17446,7 @@
           <a:lstStyle/>
           <a:p>
             <a:pPr algn="ctr"/>
+            <a:endParaRPr/>
           </a:p>
         </p:txBody>
       </p:sp>
@@ -17280,6 +17490,7 @@
           <a:lstStyle/>
           <a:p>
             <a:pPr algn="ctr"/>
+            <a:endParaRPr/>
           </a:p>
         </p:txBody>
       </p:sp>
@@ -17323,6 +17534,7 @@
           <a:lstStyle/>
           <a:p>
             <a:pPr algn="ctr"/>
+            <a:endParaRPr/>
           </a:p>
         </p:txBody>
       </p:sp>
@@ -17366,6 +17578,7 @@
           <a:lstStyle/>
           <a:p>
             <a:pPr algn="ctr"/>
+            <a:endParaRPr/>
           </a:p>
         </p:txBody>
       </p:sp>
@@ -17409,6 +17622,7 @@
           <a:lstStyle/>
           <a:p>
             <a:pPr algn="ctr"/>
+            <a:endParaRPr/>
           </a:p>
         </p:txBody>
       </p:sp>
@@ -17452,6 +17666,7 @@
           <a:lstStyle/>
           <a:p>
             <a:pPr algn="ctr"/>
+            <a:endParaRPr/>
           </a:p>
         </p:txBody>
       </p:sp>
@@ -17495,6 +17710,7 @@
           <a:lstStyle/>
           <a:p>
             <a:pPr algn="ctr"/>
+            <a:endParaRPr/>
           </a:p>
         </p:txBody>
       </p:sp>
@@ -17538,6 +17754,7 @@
           <a:lstStyle/>
           <a:p>
             <a:pPr algn="ctr"/>
+            <a:endParaRPr/>
           </a:p>
         </p:txBody>
       </p:sp>
@@ -17581,6 +17798,7 @@
           <a:lstStyle/>
           <a:p>
             <a:pPr algn="ctr"/>
+            <a:endParaRPr/>
           </a:p>
         </p:txBody>
       </p:sp>
@@ -17624,6 +17842,7 @@
           <a:lstStyle/>
           <a:p>
             <a:pPr algn="ctr"/>
+            <a:endParaRPr/>
           </a:p>
         </p:txBody>
       </p:sp>
@@ -17667,6 +17886,7 @@
           <a:lstStyle/>
           <a:p>
             <a:pPr algn="ctr"/>
+            <a:endParaRPr/>
           </a:p>
         </p:txBody>
       </p:sp>
@@ -17710,6 +17930,7 @@
           <a:lstStyle/>
           <a:p>
             <a:pPr algn="ctr"/>
+            <a:endParaRPr/>
           </a:p>
         </p:txBody>
       </p:sp>
@@ -17753,6 +17974,7 @@
           <a:lstStyle/>
           <a:p>
             <a:pPr algn="ctr"/>
+            <a:endParaRPr/>
           </a:p>
         </p:txBody>
       </p:sp>
@@ -17796,6 +18018,7 @@
           <a:lstStyle/>
           <a:p>
             <a:pPr algn="ctr"/>
+            <a:endParaRPr/>
           </a:p>
         </p:txBody>
       </p:sp>
@@ -17839,6 +18062,7 @@
           <a:lstStyle/>
           <a:p>
             <a:pPr algn="ctr"/>
+            <a:endParaRPr/>
           </a:p>
         </p:txBody>
       </p:sp>
@@ -17882,6 +18106,7 @@
           <a:lstStyle/>
           <a:p>
             <a:pPr algn="ctr"/>
+            <a:endParaRPr/>
           </a:p>
         </p:txBody>
       </p:sp>
@@ -17925,6 +18150,7 @@
           <a:lstStyle/>
           <a:p>
             <a:pPr algn="ctr"/>
+            <a:endParaRPr/>
           </a:p>
         </p:txBody>
       </p:sp>
@@ -17968,6 +18194,7 @@
           <a:lstStyle/>
           <a:p>
             <a:pPr algn="ctr"/>
+            <a:endParaRPr/>
           </a:p>
         </p:txBody>
       </p:sp>
@@ -18011,6 +18238,7 @@
           <a:lstStyle/>
           <a:p>
             <a:pPr algn="ctr"/>
+            <a:endParaRPr/>
           </a:p>
         </p:txBody>
       </p:sp>
@@ -18054,6 +18282,7 @@
           <a:lstStyle/>
           <a:p>
             <a:pPr algn="ctr"/>
+            <a:endParaRPr/>
           </a:p>
         </p:txBody>
       </p:sp>
@@ -18097,6 +18326,7 @@
           <a:lstStyle/>
           <a:p>
             <a:pPr algn="ctr"/>
+            <a:endParaRPr/>
           </a:p>
         </p:txBody>
       </p:sp>
@@ -18140,6 +18370,7 @@
           <a:lstStyle/>
           <a:p>
             <a:pPr algn="ctr"/>
+            <a:endParaRPr/>
           </a:p>
         </p:txBody>
       </p:sp>
@@ -18183,6 +18414,7 @@
           <a:lstStyle/>
           <a:p>
             <a:pPr algn="ctr"/>
+            <a:endParaRPr/>
           </a:p>
         </p:txBody>
       </p:sp>
@@ -18226,6 +18458,7 @@
           <a:lstStyle/>
           <a:p>
             <a:pPr algn="ctr"/>
+            <a:endParaRPr/>
           </a:p>
         </p:txBody>
       </p:sp>
@@ -18269,6 +18502,7 @@
           <a:lstStyle/>
           <a:p>
             <a:pPr algn="ctr"/>
+            <a:endParaRPr/>
           </a:p>
         </p:txBody>
       </p:sp>
@@ -18312,6 +18546,7 @@
           <a:lstStyle/>
           <a:p>
             <a:pPr algn="ctr"/>
+            <a:endParaRPr/>
           </a:p>
         </p:txBody>
       </p:sp>
@@ -18355,6 +18590,7 @@
           <a:lstStyle/>
           <a:p>
             <a:pPr algn="ctr"/>
+            <a:endParaRPr/>
           </a:p>
         </p:txBody>
       </p:sp>
@@ -18398,6 +18634,7 @@
           <a:lstStyle/>
           <a:p>
             <a:pPr algn="ctr"/>
+            <a:endParaRPr/>
           </a:p>
         </p:txBody>
       </p:sp>
@@ -18441,6 +18678,7 @@
           <a:lstStyle/>
           <a:p>
             <a:pPr algn="ctr"/>
+            <a:endParaRPr/>
           </a:p>
         </p:txBody>
       </p:sp>
@@ -18484,6 +18722,7 @@
           <a:lstStyle/>
           <a:p>
             <a:pPr algn="ctr"/>
+            <a:endParaRPr/>
           </a:p>
         </p:txBody>
       </p:sp>
@@ -18527,6 +18766,7 @@
           <a:lstStyle/>
           <a:p>
             <a:pPr algn="ctr"/>
+            <a:endParaRPr/>
           </a:p>
         </p:txBody>
       </p:sp>
@@ -18570,6 +18810,7 @@
           <a:lstStyle/>
           <a:p>
             <a:pPr algn="ctr"/>
+            <a:endParaRPr/>
           </a:p>
         </p:txBody>
       </p:sp>
@@ -18613,6 +18854,7 @@
           <a:lstStyle/>
           <a:p>
             <a:pPr algn="ctr"/>
+            <a:endParaRPr/>
           </a:p>
         </p:txBody>
       </p:sp>
@@ -18656,6 +18898,7 @@
           <a:lstStyle/>
           <a:p>
             <a:pPr algn="ctr"/>
+            <a:endParaRPr/>
           </a:p>
         </p:txBody>
       </p:sp>
@@ -18699,6 +18942,7 @@
           <a:lstStyle/>
           <a:p>
             <a:pPr algn="ctr"/>
+            <a:endParaRPr/>
           </a:p>
         </p:txBody>
       </p:sp>
@@ -18742,6 +18986,7 @@
           <a:lstStyle/>
           <a:p>
             <a:pPr algn="ctr"/>
+            <a:endParaRPr/>
           </a:p>
         </p:txBody>
       </p:sp>
@@ -18785,6 +19030,7 @@
           <a:lstStyle/>
           <a:p>
             <a:pPr algn="ctr"/>
+            <a:endParaRPr/>
           </a:p>
         </p:txBody>
       </p:sp>
@@ -18828,6 +19074,7 @@
           <a:lstStyle/>
           <a:p>
             <a:pPr algn="ctr"/>
+            <a:endParaRPr/>
           </a:p>
         </p:txBody>
       </p:sp>
@@ -18871,6 +19118,7 @@
           <a:lstStyle/>
           <a:p>
             <a:pPr algn="ctr"/>
+            <a:endParaRPr/>
           </a:p>
         </p:txBody>
       </p:sp>
@@ -18914,6 +19162,7 @@
           <a:lstStyle/>
           <a:p>
             <a:pPr algn="ctr"/>
+            <a:endParaRPr/>
           </a:p>
         </p:txBody>
       </p:sp>
@@ -18957,6 +19206,7 @@
           <a:lstStyle/>
           <a:p>
             <a:pPr algn="ctr"/>
+            <a:endParaRPr/>
           </a:p>
         </p:txBody>
       </p:sp>
@@ -19000,6 +19250,7 @@
           <a:lstStyle/>
           <a:p>
             <a:pPr algn="ctr"/>
+            <a:endParaRPr/>
           </a:p>
         </p:txBody>
       </p:sp>
@@ -19043,6 +19294,7 @@
           <a:lstStyle/>
           <a:p>
             <a:pPr algn="ctr"/>
+            <a:endParaRPr/>
           </a:p>
         </p:txBody>
       </p:sp>
@@ -19086,6 +19338,7 @@
           <a:lstStyle/>
           <a:p>
             <a:pPr algn="ctr"/>
+            <a:endParaRPr/>
           </a:p>
         </p:txBody>
       </p:sp>
@@ -19129,6 +19382,7 @@
           <a:lstStyle/>
           <a:p>
             <a:pPr algn="ctr"/>
+            <a:endParaRPr/>
           </a:p>
         </p:txBody>
       </p:sp>
@@ -19172,6 +19426,7 @@
           <a:lstStyle/>
           <a:p>
             <a:pPr algn="ctr"/>
+            <a:endParaRPr/>
           </a:p>
         </p:txBody>
       </p:sp>
@@ -19215,6 +19470,7 @@
           <a:lstStyle/>
           <a:p>
             <a:pPr algn="ctr"/>
+            <a:endParaRPr/>
           </a:p>
         </p:txBody>
       </p:sp>
@@ -19258,6 +19514,7 @@
           <a:lstStyle/>
           <a:p>
             <a:pPr algn="ctr"/>
+            <a:endParaRPr/>
           </a:p>
         </p:txBody>
       </p:sp>
@@ -19301,6 +19558,7 @@
           <a:lstStyle/>
           <a:p>
             <a:pPr algn="ctr"/>
+            <a:endParaRPr/>
           </a:p>
         </p:txBody>
       </p:sp>
@@ -19344,6 +19602,7 @@
           <a:lstStyle/>
           <a:p>
             <a:pPr algn="ctr"/>
+            <a:endParaRPr/>
           </a:p>
         </p:txBody>
       </p:sp>
@@ -19387,6 +19646,7 @@
           <a:lstStyle/>
           <a:p>
             <a:pPr algn="ctr"/>
+            <a:endParaRPr/>
           </a:p>
         </p:txBody>
       </p:sp>
@@ -19430,6 +19690,7 @@
           <a:lstStyle/>
           <a:p>
             <a:pPr algn="ctr"/>
+            <a:endParaRPr/>
           </a:p>
         </p:txBody>
       </p:sp>
@@ -19473,6 +19734,7 @@
           <a:lstStyle/>
           <a:p>
             <a:pPr algn="ctr"/>
+            <a:endParaRPr/>
           </a:p>
         </p:txBody>
       </p:sp>
@@ -19516,6 +19778,7 @@
           <a:lstStyle/>
           <a:p>
             <a:pPr algn="ctr"/>
+            <a:endParaRPr/>
           </a:p>
         </p:txBody>
       </p:sp>
@@ -19559,6 +19822,7 @@
           <a:lstStyle/>
           <a:p>
             <a:pPr algn="ctr"/>
+            <a:endParaRPr/>
           </a:p>
         </p:txBody>
       </p:sp>
@@ -19602,6 +19866,7 @@
           <a:lstStyle/>
           <a:p>
             <a:pPr algn="ctr"/>
+            <a:endParaRPr/>
           </a:p>
         </p:txBody>
       </p:sp>
@@ -19645,6 +19910,7 @@
           <a:lstStyle/>
           <a:p>
             <a:pPr algn="ctr"/>
+            <a:endParaRPr/>
           </a:p>
         </p:txBody>
       </p:sp>
@@ -19688,6 +19954,7 @@
           <a:lstStyle/>
           <a:p>
             <a:pPr algn="ctr"/>
+            <a:endParaRPr/>
           </a:p>
         </p:txBody>
       </p:sp>
@@ -19731,6 +19998,7 @@
           <a:lstStyle/>
           <a:p>
             <a:pPr algn="ctr"/>
+            <a:endParaRPr/>
           </a:p>
         </p:txBody>
       </p:sp>
@@ -19774,6 +20042,7 @@
           <a:lstStyle/>
           <a:p>
             <a:pPr algn="ctr"/>
+            <a:endParaRPr/>
           </a:p>
         </p:txBody>
       </p:sp>
@@ -19817,6 +20086,7 @@
           <a:lstStyle/>
           <a:p>
             <a:pPr algn="ctr"/>
+            <a:endParaRPr/>
           </a:p>
         </p:txBody>
       </p:sp>
@@ -19860,6 +20130,7 @@
           <a:lstStyle/>
           <a:p>
             <a:pPr algn="ctr"/>
+            <a:endParaRPr/>
           </a:p>
         </p:txBody>
       </p:sp>
@@ -19903,6 +20174,7 @@
           <a:lstStyle/>
           <a:p>
             <a:pPr algn="ctr"/>
+            <a:endParaRPr/>
           </a:p>
         </p:txBody>
       </p:sp>
@@ -19946,6 +20218,7 @@
           <a:lstStyle/>
           <a:p>
             <a:pPr algn="ctr"/>
+            <a:endParaRPr/>
           </a:p>
         </p:txBody>
       </p:sp>
@@ -19989,6 +20262,7 @@
           <a:lstStyle/>
           <a:p>
             <a:pPr algn="ctr"/>
+            <a:endParaRPr/>
           </a:p>
         </p:txBody>
       </p:sp>
@@ -20032,6 +20306,7 @@
           <a:lstStyle/>
           <a:p>
             <a:pPr algn="ctr"/>
+            <a:endParaRPr/>
           </a:p>
         </p:txBody>
       </p:sp>
@@ -20075,6 +20350,7 @@
           <a:lstStyle/>
           <a:p>
             <a:pPr algn="ctr"/>
+            <a:endParaRPr/>
           </a:p>
         </p:txBody>
       </p:sp>
@@ -20118,6 +20394,7 @@
           <a:lstStyle/>
           <a:p>
             <a:pPr algn="ctr"/>
+            <a:endParaRPr/>
           </a:p>
         </p:txBody>
       </p:sp>
@@ -20161,6 +20438,7 @@
           <a:lstStyle/>
           <a:p>
             <a:pPr algn="ctr"/>
+            <a:endParaRPr/>
           </a:p>
         </p:txBody>
       </p:sp>
@@ -20204,6 +20482,7 @@
           <a:lstStyle/>
           <a:p>
             <a:pPr algn="ctr"/>
+            <a:endParaRPr/>
           </a:p>
         </p:txBody>
       </p:sp>
@@ -20247,6 +20526,7 @@
           <a:lstStyle/>
           <a:p>
             <a:pPr algn="ctr"/>
+            <a:endParaRPr/>
           </a:p>
         </p:txBody>
       </p:sp>
@@ -20290,6 +20570,7 @@
           <a:lstStyle/>
           <a:p>
             <a:pPr algn="ctr"/>
+            <a:endParaRPr/>
           </a:p>
         </p:txBody>
       </p:sp>
@@ -20333,6 +20614,7 @@
           <a:lstStyle/>
           <a:p>
             <a:pPr algn="ctr"/>
+            <a:endParaRPr/>
           </a:p>
         </p:txBody>
       </p:sp>
@@ -20376,6 +20658,7 @@
           <a:lstStyle/>
           <a:p>
             <a:pPr algn="ctr"/>
+            <a:endParaRPr/>
           </a:p>
         </p:txBody>
       </p:sp>
@@ -20419,6 +20702,7 @@
           <a:lstStyle/>
           <a:p>
             <a:pPr algn="ctr"/>
+            <a:endParaRPr/>
           </a:p>
         </p:txBody>
       </p:sp>
@@ -20462,6 +20746,7 @@
           <a:lstStyle/>
           <a:p>
             <a:pPr algn="ctr"/>
+            <a:endParaRPr/>
           </a:p>
         </p:txBody>
       </p:sp>
@@ -20505,6 +20790,7 @@
           <a:lstStyle/>
           <a:p>
             <a:pPr algn="ctr"/>
+            <a:endParaRPr/>
           </a:p>
         </p:txBody>
       </p:sp>
@@ -20548,6 +20834,7 @@
           <a:lstStyle/>
           <a:p>
             <a:pPr algn="ctr"/>
+            <a:endParaRPr/>
           </a:p>
         </p:txBody>
       </p:sp>
@@ -20591,6 +20878,7 @@
           <a:lstStyle/>
           <a:p>
             <a:pPr algn="ctr"/>
+            <a:endParaRPr/>
           </a:p>
         </p:txBody>
       </p:sp>
@@ -20634,6 +20922,7 @@
           <a:lstStyle/>
           <a:p>
             <a:pPr algn="ctr"/>
+            <a:endParaRPr/>
           </a:p>
         </p:txBody>
       </p:sp>
@@ -20677,6 +20966,7 @@
           <a:lstStyle/>
           <a:p>
             <a:pPr algn="ctr"/>
+            <a:endParaRPr/>
           </a:p>
         </p:txBody>
       </p:sp>
@@ -20720,6 +21010,7 @@
           <a:lstStyle/>
           <a:p>
             <a:pPr algn="ctr"/>
+            <a:endParaRPr/>
           </a:p>
         </p:txBody>
       </p:sp>
@@ -20763,6 +21054,7 @@
           <a:lstStyle/>
           <a:p>
             <a:pPr algn="ctr"/>
+            <a:endParaRPr/>
           </a:p>
         </p:txBody>
       </p:sp>
@@ -20806,6 +21098,7 @@
           <a:lstStyle/>
           <a:p>
             <a:pPr algn="ctr"/>
+            <a:endParaRPr/>
           </a:p>
         </p:txBody>
       </p:sp>
@@ -20849,6 +21142,7 @@
           <a:lstStyle/>
           <a:p>
             <a:pPr algn="ctr"/>
+            <a:endParaRPr/>
           </a:p>
         </p:txBody>
       </p:sp>
@@ -20892,6 +21186,7 @@
           <a:lstStyle/>
           <a:p>
             <a:pPr algn="ctr"/>
+            <a:endParaRPr/>
           </a:p>
         </p:txBody>
       </p:sp>
@@ -20935,6 +21230,7 @@
           <a:lstStyle/>
           <a:p>
             <a:pPr algn="ctr"/>
+            <a:endParaRPr/>
           </a:p>
         </p:txBody>
       </p:sp>
@@ -20978,6 +21274,7 @@
           <a:lstStyle/>
           <a:p>
             <a:pPr algn="ctr"/>
+            <a:endParaRPr/>
           </a:p>
         </p:txBody>
       </p:sp>
@@ -21021,6 +21318,7 @@
           <a:lstStyle/>
           <a:p>
             <a:pPr algn="ctr"/>
+            <a:endParaRPr/>
           </a:p>
         </p:txBody>
       </p:sp>
@@ -21064,6 +21362,7 @@
           <a:lstStyle/>
           <a:p>
             <a:pPr algn="ctr"/>
+            <a:endParaRPr/>
           </a:p>
         </p:txBody>
       </p:sp>
@@ -21107,6 +21406,7 @@
           <a:lstStyle/>
           <a:p>
             <a:pPr algn="ctr"/>
+            <a:endParaRPr/>
           </a:p>
         </p:txBody>
       </p:sp>
@@ -21150,6 +21450,7 @@
           <a:lstStyle/>
           <a:p>
             <a:pPr algn="ctr"/>
+            <a:endParaRPr/>
           </a:p>
         </p:txBody>
       </p:sp>
@@ -21193,6 +21494,7 @@
           <a:lstStyle/>
           <a:p>
             <a:pPr algn="ctr"/>
+            <a:endParaRPr/>
           </a:p>
         </p:txBody>
       </p:sp>
@@ -21236,6 +21538,7 @@
           <a:lstStyle/>
           <a:p>
             <a:pPr algn="ctr"/>
+            <a:endParaRPr/>
           </a:p>
         </p:txBody>
       </p:sp>
@@ -21279,6 +21582,7 @@
           <a:lstStyle/>
           <a:p>
             <a:pPr algn="ctr"/>
+            <a:endParaRPr/>
           </a:p>
         </p:txBody>
       </p:sp>
@@ -21322,6 +21626,7 @@
           <a:lstStyle/>
           <a:p>
             <a:pPr algn="ctr"/>
+            <a:endParaRPr/>
           </a:p>
         </p:txBody>
       </p:sp>
@@ -21365,6 +21670,7 @@
           <a:lstStyle/>
           <a:p>
             <a:pPr algn="ctr"/>
+            <a:endParaRPr/>
           </a:p>
         </p:txBody>
       </p:sp>
@@ -21408,6 +21714,7 @@
           <a:lstStyle/>
           <a:p>
             <a:pPr algn="ctr"/>
+            <a:endParaRPr/>
           </a:p>
         </p:txBody>
       </p:sp>
@@ -21453,6 +21760,7 @@
           <a:lstStyle/>
           <a:p>
             <a:pPr algn="ctr"/>
+            <a:endParaRPr/>
           </a:p>
         </p:txBody>
       </p:sp>
@@ -21530,6 +21838,7 @@
           <a:lstStyle/>
           <a:p>
             <a:pPr algn="ctr"/>
+            <a:endParaRPr/>
           </a:p>
         </p:txBody>
       </p:sp>
@@ -21573,6 +21882,7 @@
           <a:lstStyle/>
           <a:p>
             <a:pPr algn="ctr"/>
+            <a:endParaRPr/>
           </a:p>
         </p:txBody>
       </p:sp>
@@ -21684,6 +21994,7 @@
           <a:lstStyle/>
           <a:p>
             <a:pPr algn="ctr"/>
+            <a:endParaRPr/>
           </a:p>
         </p:txBody>
       </p:sp>
@@ -21795,6 +22106,7 @@
           <a:lstStyle/>
           <a:p>
             <a:pPr algn="ctr"/>
+            <a:endParaRPr/>
           </a:p>
         </p:txBody>
       </p:sp>
@@ -21906,6 +22218,7 @@
           <a:lstStyle/>
           <a:p>
             <a:pPr algn="ctr"/>
+            <a:endParaRPr/>
           </a:p>
         </p:txBody>
       </p:sp>
@@ -22017,6 +22330,7 @@
           <a:lstStyle/>
           <a:p>
             <a:pPr algn="ctr"/>
+            <a:endParaRPr/>
           </a:p>
         </p:txBody>
       </p:sp>
@@ -22128,6 +22442,7 @@
           <a:lstStyle/>
           <a:p>
             <a:pPr algn="ctr"/>
+            <a:endParaRPr/>
           </a:p>
         </p:txBody>
       </p:sp>
@@ -22208,7 +22523,7 @@
 </file>
 
 <file path=ppt/slides/slide8.xml><?xml version="1.0" encoding="utf-8"?>
-<p:sld xmlns:a="http://schemas.openxmlformats.org/drawingml/2006/main" xmlns:p="http://schemas.openxmlformats.org/presentationml/2006/main" xmlns:r="http://schemas.openxmlformats.org/officeDocument/2006/relationships">
+<p:sld xmlns:a="http://schemas.openxmlformats.org/drawingml/2006/main" xmlns:r="http://schemas.openxmlformats.org/officeDocument/2006/relationships" xmlns:p="http://schemas.openxmlformats.org/presentationml/2006/main">
   <p:cSld>
     <p:bg>
       <p:bgPr>
@@ -22224,7 +22539,14 @@
         <p:cNvGrpSpPr/>
         <p:nvPr/>
       </p:nvGrpSpPr>
-      <p:grpSpPr/>
+      <p:grpSpPr>
+        <a:xfrm>
+          <a:off x="0" y="0"/>
+          <a:ext cx="0" cy="0"/>
+          <a:chOff x="0" y="0"/>
+          <a:chExt cx="0" cy="0"/>
+        </a:xfrm>
+      </p:grpSpPr>
       <p:sp>
         <p:nvSpPr>
           <p:cNvPr id="2" name="Rectangle 1"/>
@@ -22265,6 +22587,7 @@
           <a:lstStyle/>
           <a:p>
             <a:pPr algn="ctr"/>
+            <a:endParaRPr/>
           </a:p>
         </p:txBody>
       </p:sp>
@@ -22376,6 +22699,7 @@
           <a:lstStyle/>
           <a:p>
             <a:pPr algn="ctr"/>
+            <a:endParaRPr/>
           </a:p>
         </p:txBody>
       </p:sp>
@@ -22419,6 +22743,7 @@
           <a:lstStyle/>
           <a:p>
             <a:pPr algn="ctr"/>
+            <a:endParaRPr/>
           </a:p>
         </p:txBody>
       </p:sp>
@@ -22496,6 +22821,7 @@
           <a:lstStyle/>
           <a:p>
             <a:pPr algn="ctr"/>
+            <a:endParaRPr/>
           </a:p>
         </p:txBody>
       </p:sp>
@@ -22539,6 +22865,7 @@
           <a:lstStyle/>
           <a:p>
             <a:pPr algn="ctr"/>
+            <a:endParaRPr/>
           </a:p>
         </p:txBody>
       </p:sp>
@@ -22582,6 +22909,7 @@
           <a:lstStyle/>
           <a:p>
             <a:pPr algn="ctr"/>
+            <a:endParaRPr/>
           </a:p>
         </p:txBody>
       </p:sp>
@@ -22625,6 +22953,7 @@
           <a:lstStyle/>
           <a:p>
             <a:pPr algn="ctr"/>
+            <a:endParaRPr/>
           </a:p>
         </p:txBody>
       </p:sp>
@@ -22668,6 +22997,7 @@
           <a:lstStyle/>
           <a:p>
             <a:pPr algn="ctr"/>
+            <a:endParaRPr/>
           </a:p>
         </p:txBody>
       </p:sp>
@@ -22711,6 +23041,7 @@
           <a:lstStyle/>
           <a:p>
             <a:pPr algn="ctr"/>
+            <a:endParaRPr/>
           </a:p>
         </p:txBody>
       </p:sp>
@@ -22754,6 +23085,7 @@
           <a:lstStyle/>
           <a:p>
             <a:pPr algn="ctr"/>
+            <a:endParaRPr/>
           </a:p>
         </p:txBody>
       </p:sp>
@@ -22797,6 +23129,7 @@
           <a:lstStyle/>
           <a:p>
             <a:pPr algn="ctr"/>
+            <a:endParaRPr/>
           </a:p>
         </p:txBody>
       </p:sp>
@@ -22874,6 +23207,7 @@
           <a:lstStyle/>
           <a:p>
             <a:pPr algn="ctr"/>
+            <a:endParaRPr/>
           </a:p>
         </p:txBody>
       </p:sp>
@@ -22951,6 +23285,7 @@
           <a:lstStyle/>
           <a:p>
             <a:pPr algn="ctr"/>
+            <a:endParaRPr/>
           </a:p>
         </p:txBody>
       </p:sp>
@@ -23028,6 +23363,7 @@
           <a:lstStyle/>
           <a:p>
             <a:pPr algn="ctr"/>
+            <a:endParaRPr/>
           </a:p>
         </p:txBody>
       </p:sp>
@@ -23105,6 +23441,7 @@
           <a:lstStyle/>
           <a:p>
             <a:pPr algn="ctr"/>
+            <a:endParaRPr/>
           </a:p>
         </p:txBody>
       </p:sp>
@@ -23182,6 +23519,7 @@
           <a:lstStyle/>
           <a:p>
             <a:pPr algn="ctr"/>
+            <a:endParaRPr/>
           </a:p>
         </p:txBody>
       </p:sp>
@@ -23225,6 +23563,7 @@
           <a:lstStyle/>
           <a:p>
             <a:pPr algn="ctr"/>
+            <a:endParaRPr/>
           </a:p>
         </p:txBody>
       </p:sp>
@@ -23268,6 +23607,7 @@
           <a:lstStyle/>
           <a:p>
             <a:pPr algn="ctr"/>
+            <a:endParaRPr/>
           </a:p>
         </p:txBody>
       </p:sp>
@@ -23311,6 +23651,7 @@
           <a:lstStyle/>
           <a:p>
             <a:pPr algn="ctr"/>
+            <a:endParaRPr/>
           </a:p>
         </p:txBody>
       </p:sp>
@@ -23354,6 +23695,7 @@
           <a:lstStyle/>
           <a:p>
             <a:pPr algn="ctr"/>
+            <a:endParaRPr/>
           </a:p>
         </p:txBody>
       </p:sp>
@@ -23397,6 +23739,7 @@
           <a:lstStyle/>
           <a:p>
             <a:pPr algn="ctr"/>
+            <a:endParaRPr/>
           </a:p>
         </p:txBody>
       </p:sp>
@@ -23440,6 +23783,7 @@
           <a:lstStyle/>
           <a:p>
             <a:pPr algn="ctr"/>
+            <a:endParaRPr/>
           </a:p>
         </p:txBody>
       </p:sp>
@@ -23483,6 +23827,7 @@
           <a:lstStyle/>
           <a:p>
             <a:pPr algn="ctr"/>
+            <a:endParaRPr/>
           </a:p>
         </p:txBody>
       </p:sp>
@@ -23526,6 +23871,7 @@
           <a:lstStyle/>
           <a:p>
             <a:pPr algn="ctr"/>
+            <a:endParaRPr/>
           </a:p>
         </p:txBody>
       </p:sp>
@@ -23569,6 +23915,7 @@
           <a:lstStyle/>
           <a:p>
             <a:pPr algn="ctr"/>
+            <a:endParaRPr/>
           </a:p>
         </p:txBody>
       </p:sp>
@@ -23612,6 +23959,7 @@
           <a:lstStyle/>
           <a:p>
             <a:pPr algn="ctr"/>
+            <a:endParaRPr/>
           </a:p>
         </p:txBody>
       </p:sp>
@@ -23655,6 +24003,7 @@
           <a:lstStyle/>
           <a:p>
             <a:pPr algn="ctr"/>
+            <a:endParaRPr/>
           </a:p>
         </p:txBody>
       </p:sp>
@@ -23698,6 +24047,7 @@
           <a:lstStyle/>
           <a:p>
             <a:pPr algn="ctr"/>
+            <a:endParaRPr/>
           </a:p>
         </p:txBody>
       </p:sp>
@@ -23741,6 +24091,7 @@
           <a:lstStyle/>
           <a:p>
             <a:pPr algn="ctr"/>
+            <a:endParaRPr/>
           </a:p>
         </p:txBody>
       </p:sp>
@@ -23784,6 +24135,7 @@
           <a:lstStyle/>
           <a:p>
             <a:pPr algn="ctr"/>
+            <a:endParaRPr/>
           </a:p>
         </p:txBody>
       </p:sp>
@@ -24203,6 +24555,7 @@
           <a:lstStyle/>
           <a:p>
             <a:pPr algn="ctr"/>
+            <a:endParaRPr/>
           </a:p>
         </p:txBody>
       </p:sp>
@@ -24280,6 +24633,7 @@
           <a:lstStyle/>
           <a:p>
             <a:pPr algn="ctr"/>
+            <a:endParaRPr/>
           </a:p>
         </p:txBody>
       </p:sp>
@@ -24459,6 +24813,7 @@
           <a:lstStyle/>
           <a:p>
             <a:pPr algn="ctr"/>
+            <a:endParaRPr/>
           </a:p>
         </p:txBody>
       </p:sp>
@@ -24502,6 +24857,7 @@
           <a:lstStyle/>
           <a:p>
             <a:pPr algn="ctr"/>
+            <a:endParaRPr/>
           </a:p>
         </p:txBody>
       </p:sp>
@@ -24681,6 +25037,7 @@
           <a:lstStyle/>
           <a:p>
             <a:pPr algn="ctr"/>
+            <a:endParaRPr/>
           </a:p>
         </p:txBody>
       </p:sp>
@@ -24860,6 +25217,7 @@
           <a:lstStyle/>
           <a:p>
             <a:pPr algn="ctr"/>
+            <a:endParaRPr/>
           </a:p>
         </p:txBody>
       </p:sp>
@@ -25039,6 +25397,7 @@
           <a:lstStyle/>
           <a:p>
             <a:pPr algn="ctr"/>
+            <a:endParaRPr/>
           </a:p>
         </p:txBody>
       </p:sp>
@@ -25218,6 +25577,7 @@
           <a:lstStyle/>
           <a:p>
             <a:pPr algn="ctr"/>
+            <a:endParaRPr/>
           </a:p>
         </p:txBody>
       </p:sp>
@@ -25397,6 +25757,7 @@
           <a:lstStyle/>
           <a:p>
             <a:pPr algn="ctr"/>
+            <a:endParaRPr/>
           </a:p>
         </p:txBody>
       </p:sp>
@@ -25576,6 +25937,7 @@
           <a:lstStyle/>
           <a:p>
             <a:pPr algn="ctr"/>
+            <a:endParaRPr/>
           </a:p>
         </p:txBody>
       </p:sp>
@@ -25755,6 +26117,7 @@
           <a:lstStyle/>
           <a:p>
             <a:pPr algn="ctr"/>
+            <a:endParaRPr/>
           </a:p>
         </p:txBody>
       </p:sp>
@@ -25934,6 +26297,7 @@
           <a:lstStyle/>
           <a:p>
             <a:pPr algn="ctr"/>
+            <a:endParaRPr/>
           </a:p>
         </p:txBody>
       </p:sp>
@@ -26011,6 +26375,7 @@
           <a:lstStyle/>
           <a:p>
             <a:pPr algn="ctr"/>
+            <a:endParaRPr/>
           </a:p>
         </p:txBody>
       </p:sp>
@@ -26088,6 +26453,7 @@
           <a:lstStyle/>
           <a:p>
             <a:pPr algn="ctr"/>
+            <a:endParaRPr/>
           </a:p>
         </p:txBody>
       </p:sp>
@@ -26201,6 +26567,7 @@
           <a:lstStyle/>
           <a:p>
             <a:pPr algn="ctr"/>
+            <a:endParaRPr/>
           </a:p>
         </p:txBody>
       </p:sp>
@@ -26281,7 +26648,7 @@
 </file>
 
 <file path=ppt/slides/slide9.xml><?xml version="1.0" encoding="utf-8"?>
-<p:sld xmlns:a="http://schemas.openxmlformats.org/drawingml/2006/main" xmlns:p="http://schemas.openxmlformats.org/presentationml/2006/main" xmlns:r="http://schemas.openxmlformats.org/officeDocument/2006/relationships">
+<p:sld xmlns:a="http://schemas.openxmlformats.org/drawingml/2006/main" xmlns:r="http://schemas.openxmlformats.org/officeDocument/2006/relationships" xmlns:p="http://schemas.openxmlformats.org/presentationml/2006/main">
   <p:cSld>
     <p:bg>
       <p:bgPr>
@@ -26297,7 +26664,14 @@
         <p:cNvGrpSpPr/>
         <p:nvPr/>
       </p:nvGrpSpPr>
-      <p:grpSpPr/>
+      <p:grpSpPr>
+        <a:xfrm>
+          <a:off x="0" y="0"/>
+          <a:ext cx="0" cy="0"/>
+          <a:chOff x="0" y="0"/>
+          <a:chExt cx="0" cy="0"/>
+        </a:xfrm>
+      </p:grpSpPr>
       <p:sp>
         <p:nvSpPr>
           <p:cNvPr id="2" name="Rectangle 1"/>
@@ -26338,6 +26712,7 @@
           <a:lstStyle/>
           <a:p>
             <a:pPr algn="ctr"/>
+            <a:endParaRPr/>
           </a:p>
         </p:txBody>
       </p:sp>
@@ -26449,6 +26824,7 @@
           <a:lstStyle/>
           <a:p>
             <a:pPr algn="ctr"/>
+            <a:endParaRPr/>
           </a:p>
         </p:txBody>
       </p:sp>
@@ -26528,6 +26904,7 @@
           <a:lstStyle/>
           <a:p>
             <a:pPr algn="ctr"/>
+            <a:endParaRPr/>
           </a:p>
         </p:txBody>
       </p:sp>
@@ -26607,6 +26984,7 @@
           <a:lstStyle/>
           <a:p>
             <a:pPr algn="ctr"/>
+            <a:endParaRPr/>
           </a:p>
         </p:txBody>
       </p:sp>
@@ -26686,6 +27064,7 @@
           <a:lstStyle/>
           <a:p>
             <a:pPr algn="ctr"/>
+            <a:endParaRPr/>
           </a:p>
         </p:txBody>
       </p:sp>
@@ -26765,6 +27144,7 @@
           <a:lstStyle/>
           <a:p>
             <a:pPr algn="ctr"/>
+            <a:endParaRPr/>
           </a:p>
         </p:txBody>
       </p:sp>
@@ -26844,6 +27224,7 @@
           <a:lstStyle/>
           <a:p>
             <a:pPr algn="ctr"/>
+            <a:endParaRPr/>
           </a:p>
         </p:txBody>
       </p:sp>
@@ -26955,6 +27336,7 @@
           <a:lstStyle/>
           <a:p>
             <a:pPr algn="ctr"/>
+            <a:endParaRPr/>
           </a:p>
         </p:txBody>
       </p:sp>
@@ -27270,6 +27652,7 @@
           <a:lstStyle/>
           <a:p>
             <a:pPr algn="ctr"/>
+            <a:endParaRPr/>
           </a:p>
         </p:txBody>
       </p:sp>
@@ -27313,6 +27696,7 @@
           <a:lstStyle/>
           <a:p>
             <a:pPr algn="ctr"/>
+            <a:endParaRPr/>
           </a:p>
         </p:txBody>
       </p:sp>
@@ -27628,6 +28012,7 @@
           <a:lstStyle/>
           <a:p>
             <a:pPr algn="ctr"/>
+            <a:endParaRPr/>
           </a:p>
         </p:txBody>
       </p:sp>
@@ -27943,6 +28328,7 @@
           <a:lstStyle/>
           <a:p>
             <a:pPr algn="ctr"/>
+            <a:endParaRPr/>
           </a:p>
         </p:txBody>
       </p:sp>
@@ -28258,6 +28644,7 @@
           <a:lstStyle/>
           <a:p>
             <a:pPr algn="ctr"/>
+            <a:endParaRPr/>
           </a:p>
         </p:txBody>
       </p:sp>
@@ -28573,6 +28960,7 @@
           <a:lstStyle/>
           <a:p>
             <a:pPr algn="ctr"/>
+            <a:endParaRPr/>
           </a:p>
         </p:txBody>
       </p:sp>
@@ -28888,6 +29276,7 @@
           <a:lstStyle/>
           <a:p>
             <a:pPr algn="ctr"/>
+            <a:endParaRPr/>
           </a:p>
         </p:txBody>
       </p:sp>
@@ -29203,6 +29592,7 @@
           <a:lstStyle/>
           <a:p>
             <a:pPr algn="ctr"/>
+            <a:endParaRPr/>
           </a:p>
         </p:txBody>
       </p:sp>
@@ -29518,6 +29908,7 @@
           <a:lstStyle/>
           <a:p>
             <a:pPr algn="ctr"/>
+            <a:endParaRPr/>
           </a:p>
         </p:txBody>
       </p:sp>
@@ -29833,6 +30224,7 @@
           <a:lstStyle/>
           <a:p>
             <a:pPr algn="ctr"/>
+            <a:endParaRPr/>
           </a:p>
         </p:txBody>
       </p:sp>

</xml_diff>